<commit_message>
feat: v2 deck slide 10 — DEI/Ethics/Legal rows, colored borders, elegant not heavy
Replaced the 3 tall, boldly color-filled vertical-bullet columns with 3
horizontal rows: plain white background, points running as one flowing
line separated by middle-dots instead of a stacked bullet list. Each
row's outer border is colored to match its theme (teal/red/indigo)
instead of neutral gray, so the slide still reads as part of the deck's
palette without the heavy filled-box look.
</commit_message>
<xml_diff>
--- a/markdowns/05-deliverables/proposal-deck/Granite_Proposal_Defense_v2.pptx
+++ b/markdowns/05-deliverables/proposal-deck/Granite_Proposal_Defense_v2.pptx
@@ -2717,7 +2717,7 @@
         </p:nvSpPr>
         <p:spPr>
           <a:xfrm>
-            <a:off x="566928" y="1371600"/>
+            <a:off x="566928" y="1353312"/>
             <a:ext cx="11057839" cy="256032"/>
           </a:xfrm>
           <a:prstGeom prst="rect">
@@ -2756,18 +2756,23 @@
         </p:nvSpPr>
         <p:spPr>
           <a:xfrm>
-            <a:off x="587045" y="1744675"/>
-            <a:ext cx="3551834" cy="3749040"/>
+            <a:off x="566928" y="1719072"/>
+            <a:ext cx="11057839" cy="1444752"/>
           </a:xfrm>
           <a:prstGeom prst="roundRect">
             <a:avLst>
-              <a:gd name="adj" fmla="val 1545"/>
+              <a:gd name="adj" fmla="val 3165"/>
             </a:avLst>
           </a:prstGeom>
           <a:solidFill>
-            <a:srgbClr val="E4E6EB"/>
+            <a:srgbClr val="FFFFFF"/>
           </a:solidFill>
-          <a:ln/>
+          <a:ln w="19050">
+            <a:solidFill>
+              <a:srgbClr val="15707A"/>
+            </a:solidFill>
+            <a:prstDash val="solid"/>
+          </a:ln>
         </p:spPr>
       </p:sp>
       <p:sp>
@@ -2778,18 +2783,73 @@
         </p:nvSpPr>
         <p:spPr>
           <a:xfrm>
-            <a:off x="566928" y="1719072"/>
-            <a:ext cx="3551834" cy="3749040"/>
-          </a:xfrm>
-          <a:prstGeom prst="roundRect">
-            <a:avLst>
-              <a:gd name="adj" fmla="val 1545"/>
-            </a:avLst>
+            <a:off x="566928" y="1810512"/>
+            <a:ext cx="45720" cy="1261872"/>
+          </a:xfrm>
+          <a:prstGeom prst="rect">
+            <a:avLst/>
           </a:prstGeom>
           <a:solidFill>
-            <a:srgbClr val="E3EFF1"/>
+            <a:srgbClr val="15707A"/>
           </a:solidFill>
-          <a:ln w="9525">
+          <a:ln/>
+        </p:spPr>
+      </p:sp>
+      <p:sp>
+        <p:nvSpPr>
+          <p:cNvPr id="13" name="Text 11"/>
+          <p:cNvSpPr txBox="1"/>
+          <p:nvPr/>
+        </p:nvSpPr>
+        <p:spPr>
+          <a:xfrm>
+            <a:off x="786384" y="1719072"/>
+            <a:ext cx="1197864" cy="1444752"/>
+          </a:xfrm>
+          <a:prstGeom prst="rect">
+            <a:avLst/>
+          </a:prstGeom>
+          <a:noFill/>
+          <a:ln/>
+        </p:spPr>
+        <p:txBody>
+          <a:bodyPr wrap="square" lIns="0" tIns="0" rIns="0" bIns="0" rtlCol="0" anchor="ctr"/>
+          <a:lstStyle/>
+          <a:p>
+            <a:pPr indent="0" marL="0">
+              <a:buNone/>
+            </a:pPr>
+            <a:r>
+              <a:rPr lang="en-US" sz="1500" b="1" spc="80" kern="0" dirty="0">
+                <a:solidFill>
+                  <a:srgbClr val="15707A"/>
+                </a:solidFill>
+                <a:latin typeface="Consolas" pitchFamily="34" charset="0"/>
+                <a:ea typeface="Consolas" pitchFamily="34" charset="-122"/>
+                <a:cs typeface="Consolas" pitchFamily="34" charset="-120"/>
+              </a:rPr>
+              <a:t>DEI</a:t>
+            </a:r>
+            <a:endParaRPr lang="en-US" sz="1500" dirty="0"/>
+          </a:p>
+        </p:txBody>
+      </p:sp>
+      <p:sp>
+        <p:nvSpPr>
+          <p:cNvPr id="14" name="Shape 12"/>
+          <p:cNvSpPr/>
+          <p:nvPr/>
+        </p:nvSpPr>
+        <p:spPr>
+          <a:xfrm>
+            <a:off x="2084832" y="1901952"/>
+            <a:ext cx="0" cy="1078992"/>
+          </a:xfrm>
+          <a:prstGeom prst="line">
+            <a:avLst/>
+          </a:prstGeom>
+          <a:noFill/>
+          <a:ln w="12700">
             <a:solidFill>
               <a:srgbClr val="D9DCE3"/>
             </a:solidFill>
@@ -2799,34 +2859,14 @@
       </p:sp>
       <p:sp>
         <p:nvSpPr>
-          <p:cNvPr id="13" name="Shape 11"/>
-          <p:cNvSpPr/>
-          <p:nvPr/>
-        </p:nvSpPr>
-        <p:spPr>
-          <a:xfrm>
-            <a:off x="566928" y="1773936"/>
-            <a:ext cx="41148" cy="3639312"/>
-          </a:xfrm>
-          <a:prstGeom prst="rect">
-            <a:avLst/>
-          </a:prstGeom>
-          <a:solidFill>
-            <a:srgbClr val="15707A"/>
-          </a:solidFill>
-          <a:ln/>
-        </p:spPr>
-      </p:sp>
-      <p:sp>
-        <p:nvSpPr>
-          <p:cNvPr id="14" name="Text 12"/>
+          <p:cNvPr id="15" name="Text 13"/>
           <p:cNvSpPr txBox="1"/>
           <p:nvPr/>
         </p:nvSpPr>
         <p:spPr>
           <a:xfrm>
-            <a:off x="768096" y="1865376"/>
-            <a:ext cx="3149498" cy="292608"/>
+            <a:off x="2185416" y="1719072"/>
+            <a:ext cx="9256471" cy="1444752"/>
           </a:xfrm>
           <a:prstGeom prst="rect">
             <a:avLst/>
@@ -2839,18 +2879,107 @@
           <a:lstStyle/>
           <a:p>
             <a:pPr indent="0" marL="0">
+              <a:lnSpc>
+                <a:spcPct val="135000"/>
+              </a:lnSpc>
+              <a:buNone/>
+            </a:pPr>
+            <a:r>
+              <a:rPr lang="en-US" sz="1400" dirty="0">
+                <a:solidFill>
+                  <a:srgbClr val="1B202A"/>
+                </a:solidFill>
+                <a:latin typeface="Calibri" pitchFamily="34" charset="0"/>
+                <a:ea typeface="Calibri" pitchFamily="34" charset="-122"/>
+                <a:cs typeface="Calibri" pitchFamily="34" charset="-120"/>
+              </a:rPr>
+              <a:t>Open-source release widens access — SDG 9 access-equity     ·     Colour + text + shape, never colour alone — WCAG owed by Final-1     ·     Accuracy claims stated as English-only</a:t>
+            </a:r>
+            <a:endParaRPr lang="en-US" sz="1400" dirty="0"/>
+          </a:p>
+        </p:txBody>
+      </p:sp>
+      <p:sp>
+        <p:nvSpPr>
+          <p:cNvPr id="16" name="Shape 14"/>
+          <p:cNvSpPr/>
+          <p:nvPr/>
+        </p:nvSpPr>
+        <p:spPr>
+          <a:xfrm>
+            <a:off x="566928" y="3328416"/>
+            <a:ext cx="11057839" cy="1444752"/>
+          </a:xfrm>
+          <a:prstGeom prst="roundRect">
+            <a:avLst>
+              <a:gd name="adj" fmla="val 3165"/>
+            </a:avLst>
+          </a:prstGeom>
+          <a:solidFill>
+            <a:srgbClr val="FFFFFF"/>
+          </a:solidFill>
+          <a:ln w="19050">
+            <a:solidFill>
+              <a:srgbClr val="A83A30"/>
+            </a:solidFill>
+            <a:prstDash val="solid"/>
+          </a:ln>
+        </p:spPr>
+      </p:sp>
+      <p:sp>
+        <p:nvSpPr>
+          <p:cNvPr id="17" name="Shape 15"/>
+          <p:cNvSpPr/>
+          <p:nvPr/>
+        </p:nvSpPr>
+        <p:spPr>
+          <a:xfrm>
+            <a:off x="566928" y="3419856"/>
+            <a:ext cx="45720" cy="1261872"/>
+          </a:xfrm>
+          <a:prstGeom prst="rect">
+            <a:avLst/>
+          </a:prstGeom>
+          <a:solidFill>
+            <a:srgbClr val="A83A30"/>
+          </a:solidFill>
+          <a:ln/>
+        </p:spPr>
+      </p:sp>
+      <p:sp>
+        <p:nvSpPr>
+          <p:cNvPr id="18" name="Text 16"/>
+          <p:cNvSpPr txBox="1"/>
+          <p:nvPr/>
+        </p:nvSpPr>
+        <p:spPr>
+          <a:xfrm>
+            <a:off x="786384" y="3328416"/>
+            <a:ext cx="1197864" cy="1444752"/>
+          </a:xfrm>
+          <a:prstGeom prst="rect">
+            <a:avLst/>
+          </a:prstGeom>
+          <a:noFill/>
+          <a:ln/>
+        </p:spPr>
+        <p:txBody>
+          <a:bodyPr wrap="square" lIns="0" tIns="0" rIns="0" bIns="0" rtlCol="0" anchor="ctr"/>
+          <a:lstStyle/>
+          <a:p>
+            <a:pPr indent="0" marL="0">
               <a:buNone/>
             </a:pPr>
             <a:r>
               <a:rPr lang="en-US" sz="1500" b="1" spc="80" kern="0" dirty="0">
                 <a:solidFill>
-                  <a:srgbClr val="15707A"/>
+                  <a:srgbClr val="A83A30"/>
                 </a:solidFill>
                 <a:latin typeface="Consolas" pitchFamily="34" charset="0"/>
                 <a:ea typeface="Consolas" pitchFamily="34" charset="-122"/>
                 <a:cs typeface="Consolas" pitchFamily="34" charset="-120"/>
               </a:rPr>
-              <a:t>DEI</a:t>
+              <a:t>ETHICAL</a:t>
             </a:r>
             <a:endParaRPr lang="en-US" sz="1500" dirty="0"/>
           </a:p>
@@ -2858,131 +2987,20 @@
       </p:sp>
       <p:sp>
         <p:nvSpPr>
-          <p:cNvPr id="15" name="Text 13"/>
-          <p:cNvSpPr txBox="1"/>
-          <p:nvPr/>
-        </p:nvSpPr>
-        <p:spPr>
-          <a:xfrm>
-            <a:off x="768096" y="2377440"/>
-            <a:ext cx="3149498" cy="2926080"/>
-          </a:xfrm>
-          <a:prstGeom prst="rect">
+          <p:cNvPr id="19" name="Shape 17"/>
+          <p:cNvSpPr/>
+          <p:nvPr/>
+        </p:nvSpPr>
+        <p:spPr>
+          <a:xfrm>
+            <a:off x="2084832" y="3511296"/>
+            <a:ext cx="0" cy="1078992"/>
+          </a:xfrm>
+          <a:prstGeom prst="line">
             <a:avLst/>
           </a:prstGeom>
           <a:noFill/>
-          <a:ln/>
-        </p:spPr>
-        <p:txBody>
-          <a:bodyPr wrap="square" lIns="0" tIns="0" rIns="0" bIns="0" rtlCol="0" anchor="ctr"/>
-          <a:lstStyle/>
-          <a:p>
-            <a:pPr marL="190500" indent="-190500">
-              <a:spcAft>
-                <a:spcPts val="2600"/>
-              </a:spcAft>
-              <a:buSzPct val="100000"/>
-              <a:buChar char="▪"/>
-            </a:pPr>
-            <a:r>
-              <a:rPr lang="en-US" sz="1650" dirty="0">
-                <a:solidFill>
-                  <a:srgbClr val="1B202A"/>
-                </a:solidFill>
-                <a:latin typeface="Calibri" pitchFamily="34" charset="0"/>
-                <a:ea typeface="Calibri" pitchFamily="34" charset="-122"/>
-                <a:cs typeface="Calibri" pitchFamily="34" charset="-120"/>
-              </a:rPr>
-              <a:t>Open-source release widens access — SDG 9 access-equity</a:t>
-            </a:r>
-            <a:endParaRPr lang="en-US" sz="1650" dirty="0"/>
-          </a:p>
-          <a:p>
-            <a:pPr marL="190500" indent="-190500">
-              <a:spcAft>
-                <a:spcPts val="2600"/>
-              </a:spcAft>
-              <a:buSzPct val="100000"/>
-              <a:buChar char="▪"/>
-            </a:pPr>
-            <a:r>
-              <a:rPr lang="en-US" sz="1650" dirty="0">
-                <a:solidFill>
-                  <a:srgbClr val="1B202A"/>
-                </a:solidFill>
-                <a:latin typeface="Calibri" pitchFamily="34" charset="0"/>
-                <a:ea typeface="Calibri" pitchFamily="34" charset="-122"/>
-                <a:cs typeface="Calibri" pitchFamily="34" charset="-120"/>
-              </a:rPr>
-              <a:t>Colour + text + shape, never colour alone — WCAG owed by Final-1</a:t>
-            </a:r>
-            <a:endParaRPr lang="en-US" sz="1650" dirty="0"/>
-          </a:p>
-          <a:p>
-            <a:pPr marL="190500" indent="-190500">
-              <a:spcAft>
-                <a:spcPts val="2600"/>
-              </a:spcAft>
-              <a:buSzPct val="100000"/>
-              <a:buChar char="▪"/>
-            </a:pPr>
-            <a:r>
-              <a:rPr lang="en-US" sz="1650" dirty="0">
-                <a:solidFill>
-                  <a:srgbClr val="1B202A"/>
-                </a:solidFill>
-                <a:latin typeface="Calibri" pitchFamily="34" charset="0"/>
-                <a:ea typeface="Calibri" pitchFamily="34" charset="-122"/>
-                <a:cs typeface="Calibri" pitchFamily="34" charset="-120"/>
-              </a:rPr>
-              <a:t>Accuracy claims stated as English-only</a:t>
-            </a:r>
-            <a:endParaRPr lang="en-US" sz="1650" dirty="0"/>
-          </a:p>
-        </p:txBody>
-      </p:sp>
-      <p:sp>
-        <p:nvSpPr>
-          <p:cNvPr id="16" name="Shape 14"/>
-          <p:cNvSpPr/>
-          <p:nvPr/>
-        </p:nvSpPr>
-        <p:spPr>
-          <a:xfrm>
-            <a:off x="4340047" y="1744675"/>
-            <a:ext cx="3551834" cy="3749040"/>
-          </a:xfrm>
-          <a:prstGeom prst="roundRect">
-            <a:avLst>
-              <a:gd name="adj" fmla="val 1545"/>
-            </a:avLst>
-          </a:prstGeom>
-          <a:solidFill>
-            <a:srgbClr val="E4E6EB"/>
-          </a:solidFill>
-          <a:ln/>
-        </p:spPr>
-      </p:sp>
-      <p:sp>
-        <p:nvSpPr>
-          <p:cNvPr id="17" name="Shape 15"/>
-          <p:cNvSpPr/>
-          <p:nvPr/>
-        </p:nvSpPr>
-        <p:spPr>
-          <a:xfrm>
-            <a:off x="4319930" y="1719072"/>
-            <a:ext cx="3551834" cy="3749040"/>
-          </a:xfrm>
-          <a:prstGeom prst="roundRect">
-            <a:avLst>
-              <a:gd name="adj" fmla="val 1545"/>
-            </a:avLst>
-          </a:prstGeom>
-          <a:solidFill>
-            <a:srgbClr val="F6E6E3"/>
-          </a:solidFill>
-          <a:ln w="9525">
+          <a:ln w="12700">
             <a:solidFill>
               <a:srgbClr val="D9DCE3"/>
             </a:solidFill>
@@ -2992,34 +3010,14 @@
       </p:sp>
       <p:sp>
         <p:nvSpPr>
-          <p:cNvPr id="18" name="Shape 16"/>
-          <p:cNvSpPr/>
-          <p:nvPr/>
-        </p:nvSpPr>
-        <p:spPr>
-          <a:xfrm>
-            <a:off x="4319930" y="1773936"/>
-            <a:ext cx="41148" cy="3639312"/>
-          </a:xfrm>
-          <a:prstGeom prst="rect">
-            <a:avLst/>
-          </a:prstGeom>
-          <a:solidFill>
-            <a:srgbClr val="A83A30"/>
-          </a:solidFill>
-          <a:ln/>
-        </p:spPr>
-      </p:sp>
-      <p:sp>
-        <p:nvSpPr>
-          <p:cNvPr id="19" name="Text 17"/>
+          <p:cNvPr id="20" name="Text 18"/>
           <p:cNvSpPr txBox="1"/>
           <p:nvPr/>
         </p:nvSpPr>
         <p:spPr>
           <a:xfrm>
-            <a:off x="4521098" y="1865376"/>
-            <a:ext cx="3149498" cy="292608"/>
+            <a:off x="2185416" y="3328416"/>
+            <a:ext cx="9256471" cy="1444752"/>
           </a:xfrm>
           <a:prstGeom prst="rect">
             <a:avLst/>
@@ -3032,18 +3030,107 @@
           <a:lstStyle/>
           <a:p>
             <a:pPr indent="0" marL="0">
+              <a:lnSpc>
+                <a:spcPct val="135000"/>
+              </a:lnSpc>
+              <a:buNone/>
+            </a:pPr>
+            <a:r>
+              <a:rPr lang="en-US" sz="1400" dirty="0">
+                <a:solidFill>
+                  <a:srgbClr val="1B202A"/>
+                </a:solidFill>
+                <a:latin typeface="Calibri" pitchFamily="34" charset="0"/>
+                <a:ea typeface="Calibri" pitchFamily="34" charset="-122"/>
+                <a:cs typeface="Calibri" pitchFamily="34" charset="-120"/>
+              </a:rPr>
+              <a:t>Advisory only — every repair is human-gated     ·     Consent for real trace data; injection only on consenting systems     ·     Negative results published as found — Spike 7 not buried</a:t>
+            </a:r>
+            <a:endParaRPr lang="en-US" sz="1400" dirty="0"/>
+          </a:p>
+        </p:txBody>
+      </p:sp>
+      <p:sp>
+        <p:nvSpPr>
+          <p:cNvPr id="21" name="Shape 19"/>
+          <p:cNvSpPr/>
+          <p:nvPr/>
+        </p:nvSpPr>
+        <p:spPr>
+          <a:xfrm>
+            <a:off x="566928" y="4937760"/>
+            <a:ext cx="11057839" cy="1444752"/>
+          </a:xfrm>
+          <a:prstGeom prst="roundRect">
+            <a:avLst>
+              <a:gd name="adj" fmla="val 3165"/>
+            </a:avLst>
+          </a:prstGeom>
+          <a:solidFill>
+            <a:srgbClr val="FFFFFF"/>
+          </a:solidFill>
+          <a:ln w="19050">
+            <a:solidFill>
+              <a:srgbClr val="31558F"/>
+            </a:solidFill>
+            <a:prstDash val="solid"/>
+          </a:ln>
+        </p:spPr>
+      </p:sp>
+      <p:sp>
+        <p:nvSpPr>
+          <p:cNvPr id="22" name="Shape 20"/>
+          <p:cNvSpPr/>
+          <p:nvPr/>
+        </p:nvSpPr>
+        <p:spPr>
+          <a:xfrm>
+            <a:off x="566928" y="5029200"/>
+            <a:ext cx="45720" cy="1261872"/>
+          </a:xfrm>
+          <a:prstGeom prst="rect">
+            <a:avLst/>
+          </a:prstGeom>
+          <a:solidFill>
+            <a:srgbClr val="31558F"/>
+          </a:solidFill>
+          <a:ln/>
+        </p:spPr>
+      </p:sp>
+      <p:sp>
+        <p:nvSpPr>
+          <p:cNvPr id="23" name="Text 21"/>
+          <p:cNvSpPr txBox="1"/>
+          <p:nvPr/>
+        </p:nvSpPr>
+        <p:spPr>
+          <a:xfrm>
+            <a:off x="786384" y="4937760"/>
+            <a:ext cx="1197864" cy="1444752"/>
+          </a:xfrm>
+          <a:prstGeom prst="rect">
+            <a:avLst/>
+          </a:prstGeom>
+          <a:noFill/>
+          <a:ln/>
+        </p:spPr>
+        <p:txBody>
+          <a:bodyPr wrap="square" lIns="0" tIns="0" rIns="0" bIns="0" rtlCol="0" anchor="ctr"/>
+          <a:lstStyle/>
+          <a:p>
+            <a:pPr indent="0" marL="0">
               <a:buNone/>
             </a:pPr>
             <a:r>
               <a:rPr lang="en-US" sz="1500" b="1" spc="80" kern="0" dirty="0">
                 <a:solidFill>
-                  <a:srgbClr val="A83A30"/>
+                  <a:srgbClr val="31558F"/>
                 </a:solidFill>
                 <a:latin typeface="Consolas" pitchFamily="34" charset="0"/>
                 <a:ea typeface="Consolas" pitchFamily="34" charset="-122"/>
                 <a:cs typeface="Consolas" pitchFamily="34" charset="-120"/>
               </a:rPr>
-              <a:t>ETHICAL</a:t>
+              <a:t>LEGAL</a:t>
             </a:r>
             <a:endParaRPr lang="en-US" sz="1500" dirty="0"/>
           </a:p>
@@ -3051,131 +3138,20 @@
       </p:sp>
       <p:sp>
         <p:nvSpPr>
-          <p:cNvPr id="20" name="Text 18"/>
-          <p:cNvSpPr txBox="1"/>
-          <p:nvPr/>
-        </p:nvSpPr>
-        <p:spPr>
-          <a:xfrm>
-            <a:off x="4521098" y="2377440"/>
-            <a:ext cx="3149498" cy="2926080"/>
-          </a:xfrm>
-          <a:prstGeom prst="rect">
+          <p:cNvPr id="24" name="Shape 22"/>
+          <p:cNvSpPr/>
+          <p:nvPr/>
+        </p:nvSpPr>
+        <p:spPr>
+          <a:xfrm>
+            <a:off x="2084832" y="5120640"/>
+            <a:ext cx="0" cy="1078992"/>
+          </a:xfrm>
+          <a:prstGeom prst="line">
             <a:avLst/>
           </a:prstGeom>
           <a:noFill/>
-          <a:ln/>
-        </p:spPr>
-        <p:txBody>
-          <a:bodyPr wrap="square" lIns="0" tIns="0" rIns="0" bIns="0" rtlCol="0" anchor="ctr"/>
-          <a:lstStyle/>
-          <a:p>
-            <a:pPr marL="190500" indent="-190500">
-              <a:spcAft>
-                <a:spcPts val="2600"/>
-              </a:spcAft>
-              <a:buSzPct val="100000"/>
-              <a:buChar char="▪"/>
-            </a:pPr>
-            <a:r>
-              <a:rPr lang="en-US" sz="1650" dirty="0">
-                <a:solidFill>
-                  <a:srgbClr val="1B202A"/>
-                </a:solidFill>
-                <a:latin typeface="Calibri" pitchFamily="34" charset="0"/>
-                <a:ea typeface="Calibri" pitchFamily="34" charset="-122"/>
-                <a:cs typeface="Calibri" pitchFamily="34" charset="-120"/>
-              </a:rPr>
-              <a:t>Advisory only — every repair is human-gated</a:t>
-            </a:r>
-            <a:endParaRPr lang="en-US" sz="1650" dirty="0"/>
-          </a:p>
-          <a:p>
-            <a:pPr marL="190500" indent="-190500">
-              <a:spcAft>
-                <a:spcPts val="2600"/>
-              </a:spcAft>
-              <a:buSzPct val="100000"/>
-              <a:buChar char="▪"/>
-            </a:pPr>
-            <a:r>
-              <a:rPr lang="en-US" sz="1650" dirty="0">
-                <a:solidFill>
-                  <a:srgbClr val="1B202A"/>
-                </a:solidFill>
-                <a:latin typeface="Calibri" pitchFamily="34" charset="0"/>
-                <a:ea typeface="Calibri" pitchFamily="34" charset="-122"/>
-                <a:cs typeface="Calibri" pitchFamily="34" charset="-120"/>
-              </a:rPr>
-              <a:t>Consent for real trace data; injection only on consenting systems</a:t>
-            </a:r>
-            <a:endParaRPr lang="en-US" sz="1650" dirty="0"/>
-          </a:p>
-          <a:p>
-            <a:pPr marL="190500" indent="-190500">
-              <a:spcAft>
-                <a:spcPts val="2600"/>
-              </a:spcAft>
-              <a:buSzPct val="100000"/>
-              <a:buChar char="▪"/>
-            </a:pPr>
-            <a:r>
-              <a:rPr lang="en-US" sz="1650" dirty="0">
-                <a:solidFill>
-                  <a:srgbClr val="1B202A"/>
-                </a:solidFill>
-                <a:latin typeface="Calibri" pitchFamily="34" charset="0"/>
-                <a:ea typeface="Calibri" pitchFamily="34" charset="-122"/>
-                <a:cs typeface="Calibri" pitchFamily="34" charset="-120"/>
-              </a:rPr>
-              <a:t>Negative results published as found — Spike 7 not buried</a:t>
-            </a:r>
-            <a:endParaRPr lang="en-US" sz="1650" dirty="0"/>
-          </a:p>
-        </p:txBody>
-      </p:sp>
-      <p:sp>
-        <p:nvSpPr>
-          <p:cNvPr id="21" name="Shape 19"/>
-          <p:cNvSpPr/>
-          <p:nvPr/>
-        </p:nvSpPr>
-        <p:spPr>
-          <a:xfrm>
-            <a:off x="8093050" y="1744675"/>
-            <a:ext cx="3551834" cy="3749040"/>
-          </a:xfrm>
-          <a:prstGeom prst="roundRect">
-            <a:avLst>
-              <a:gd name="adj" fmla="val 1545"/>
-            </a:avLst>
-          </a:prstGeom>
-          <a:solidFill>
-            <a:srgbClr val="E4E6EB"/>
-          </a:solidFill>
-          <a:ln/>
-        </p:spPr>
-      </p:sp>
-      <p:sp>
-        <p:nvSpPr>
-          <p:cNvPr id="22" name="Shape 20"/>
-          <p:cNvSpPr/>
-          <p:nvPr/>
-        </p:nvSpPr>
-        <p:spPr>
-          <a:xfrm>
-            <a:off x="8072933" y="1719072"/>
-            <a:ext cx="3551834" cy="3749040"/>
-          </a:xfrm>
-          <a:prstGeom prst="roundRect">
-            <a:avLst>
-              <a:gd name="adj" fmla="val 1545"/>
-            </a:avLst>
-          </a:prstGeom>
-          <a:solidFill>
-            <a:srgbClr val="E4E9F2"/>
-          </a:solidFill>
-          <a:ln w="9525">
+          <a:ln w="12700">
             <a:solidFill>
               <a:srgbClr val="D9DCE3"/>
             </a:solidFill>
@@ -3185,34 +3161,14 @@
       </p:sp>
       <p:sp>
         <p:nvSpPr>
-          <p:cNvPr id="23" name="Shape 21"/>
-          <p:cNvSpPr/>
-          <p:nvPr/>
-        </p:nvSpPr>
-        <p:spPr>
-          <a:xfrm>
-            <a:off x="8072933" y="1773936"/>
-            <a:ext cx="41148" cy="3639312"/>
-          </a:xfrm>
-          <a:prstGeom prst="rect">
-            <a:avLst/>
-          </a:prstGeom>
-          <a:solidFill>
-            <a:srgbClr val="31558F"/>
-          </a:solidFill>
-          <a:ln/>
-        </p:spPr>
-      </p:sp>
-      <p:sp>
-        <p:nvSpPr>
-          <p:cNvPr id="24" name="Text 22"/>
+          <p:cNvPr id="25" name="Text 23"/>
           <p:cNvSpPr txBox="1"/>
           <p:nvPr/>
         </p:nvSpPr>
         <p:spPr>
           <a:xfrm>
-            <a:off x="8274101" y="1865376"/>
-            <a:ext cx="3149498" cy="292608"/>
+            <a:off x="2185416" y="4937760"/>
+            <a:ext cx="9256471" cy="1444752"/>
           </a:xfrm>
           <a:prstGeom prst="rect">
             <a:avLst/>
@@ -3225,53 +3181,13 @@
           <a:lstStyle/>
           <a:p>
             <a:pPr indent="0" marL="0">
-              <a:buNone/>
-            </a:pPr>
-            <a:r>
-              <a:rPr lang="en-US" sz="1500" b="1" spc="80" kern="0" dirty="0">
-                <a:solidFill>
-                  <a:srgbClr val="31558F"/>
-                </a:solidFill>
-                <a:latin typeface="Consolas" pitchFamily="34" charset="0"/>
-                <a:ea typeface="Consolas" pitchFamily="34" charset="-122"/>
-                <a:cs typeface="Consolas" pitchFamily="34" charset="-120"/>
-              </a:rPr>
-              <a:t>LEGAL / PROFESSIONAL</a:t>
-            </a:r>
-            <a:endParaRPr lang="en-US" sz="1500" dirty="0"/>
-          </a:p>
-        </p:txBody>
-      </p:sp>
-      <p:sp>
-        <p:nvSpPr>
-          <p:cNvPr id="25" name="Text 23"/>
-          <p:cNvSpPr txBox="1"/>
-          <p:nvPr/>
-        </p:nvSpPr>
-        <p:spPr>
-          <a:xfrm>
-            <a:off x="8274101" y="2377440"/>
-            <a:ext cx="3149498" cy="2926080"/>
-          </a:xfrm>
-          <a:prstGeom prst="rect">
-            <a:avLst/>
-          </a:prstGeom>
-          <a:noFill/>
-          <a:ln/>
-        </p:spPr>
-        <p:txBody>
-          <a:bodyPr wrap="square" lIns="0" tIns="0" rIns="0" bIns="0" rtlCol="0" anchor="ctr"/>
-          <a:lstStyle/>
-          <a:p>
-            <a:pPr marL="190500" indent="-190500">
-              <a:spcAft>
-                <a:spcPts val="2600"/>
-              </a:spcAft>
-              <a:buSzPct val="100000"/>
-              <a:buChar char="▪"/>
-            </a:pPr>
-            <a:r>
-              <a:rPr lang="en-US" sz="1650" dirty="0">
+              <a:lnSpc>
+                <a:spcPct val="135000"/>
+              </a:lnSpc>
+              <a:buNone/>
+            </a:pPr>
+            <a:r>
+              <a:rPr lang="en-US" sz="1400" dirty="0">
                 <a:solidFill>
                   <a:srgbClr val="1B202A"/>
                 </a:solidFill>
@@ -3279,51 +3195,9 @@
                 <a:ea typeface="Calibri" pitchFamily="34" charset="-122"/>
                 <a:cs typeface="Calibri" pitchFamily="34" charset="-120"/>
               </a:rPr>
-              <a:t>Who&amp;When · GSM8K · tau-bench — all MIT, confirmed against the LICENSE file</a:t>
-            </a:r>
-            <a:endParaRPr lang="en-US" sz="1650" dirty="0"/>
-          </a:p>
-          <a:p>
-            <a:pPr marL="190500" indent="-190500">
-              <a:spcAft>
-                <a:spcPts val="2600"/>
-              </a:spcAft>
-              <a:buSzPct val="100000"/>
-              <a:buChar char="▪"/>
-            </a:pPr>
-            <a:r>
-              <a:rPr lang="en-US" sz="1650" dirty="0">
-                <a:solidFill>
-                  <a:srgbClr val="1B202A"/>
-                </a:solidFill>
-                <a:latin typeface="Calibri" pitchFamily="34" charset="0"/>
-                <a:ea typeface="Calibri" pitchFamily="34" charset="-122"/>
-                <a:cs typeface="Calibri" pitchFamily="34" charset="-120"/>
-              </a:rPr>
-              <a:t>Released artefacts carry MIT / CC BY 4.0</a:t>
-            </a:r>
-            <a:endParaRPr lang="en-US" sz="1650" dirty="0"/>
-          </a:p>
-          <a:p>
-            <a:pPr marL="190500" indent="-190500">
-              <a:spcAft>
-                <a:spcPts val="2600"/>
-              </a:spcAft>
-              <a:buSzPct val="100000"/>
-              <a:buChar char="▪"/>
-            </a:pPr>
-            <a:r>
-              <a:rPr lang="en-US" sz="1650" dirty="0">
-                <a:solidFill>
-                  <a:srgbClr val="1B202A"/>
-                </a:solidFill>
-                <a:latin typeface="Calibri" pitchFamily="34" charset="0"/>
-                <a:ea typeface="Calibri" pitchFamily="34" charset="-122"/>
-                <a:cs typeface="Calibri" pitchFamily="34" charset="-120"/>
-              </a:rPr>
-              <a:t>AI usage logged per session and disclosed to the team throughout</a:t>
-            </a:r>
-            <a:endParaRPr lang="en-US" sz="1650" dirty="0"/>
+              <a:t>Who&amp;When · GSM8K · tau-bench — all MIT, confirmed against the LICENSE file     ·     Released artefacts carry MIT / CC BY 4.0     ·     AI usage logged per session and disclosed to the team throughout</a:t>
+            </a:r>
+            <a:endParaRPr lang="en-US" sz="1400" dirty="0"/>
           </a:p>
         </p:txBody>
       </p:sp>

</xml_diff>

<commit_message>
feat: v2 deck - slide 5 CCP down to 5, slide 6 diagram removed, slide 7/8 decluttered
Slide 5: CCP grid down from 9/8 to the 5 strongest, most classic
arguments (Conflicting requirements, No obvious solution, Depth of
knowledge, Beyond standard practice, Ill-defined cause), renumbered 1-5
with no gaps, laid out as elegant full-width rows (same style as slide
10) instead of a grid of boxes. The diagram is removed entirely.

Slide 6: grammar-flag fix on the Contribution line.

Slide 7: Operator Workflow diagram removed (it repeated logic already
on slide 5); the prototype screenshot now stretches to the full slide
width instead.

Slide 8: every heading trimmed to 2-3 points instead of 4-5 (Metrics,
Success bands, Top risks/fallback), with card heights rebalanced so the
columns still fill the available space evenly.
</commit_message>
<xml_diff>
--- a/markdowns/05-deliverables/proposal-deck/Granite_Proposal_Defense_v2.pptx
+++ b/markdowns/05-deliverables/proposal-deck/Granite_Proposal_Defense_v2.pptx
@@ -1198,7 +1198,7 @@
           <a:p>
             <a:r>
               <a:rPr lang="en-US" dirty="0"/>
-              <a:t>This is the slide the panel uses to decide whether the project deserves capstone status. Concede up front that a trace-capture-plus-LLM-guess wrapper is a weekend's work, then name precisely what such a version would get wrong: no benchmark on unseen architectures, no way to tell a silent failure from a correct answer, no measured false-positive rate on clean controls, no evidence its fix works. NOTE — on-slide badges are renumbered 1-6 for readability; they are NOT the Seoul Accord characteristic numbers. Badge 4 on the slide = real characteristic 6 (Diverse stakeholders) — it's amber on purpose, say so before they spot it. Badge 6 on the slide = real characteristic 9 (Ill-defined cause) — read its resolution aloud if pressed on complexity; the diagram on the right is that resolution, drawn: hypothesis generation, evidence-grounding, and the controlled-replay loop that gates every fix. Real characteristics 4, 5 and 8 (Unfamiliar issues / Beyond standard practice / Interdependence) are off-slide entirely but still true and still fully argued in Granite_CCP_Justification_Seoul_Accord.docx and CCP_Characteristics_Not_On_Slide.md — cover them only if asked directly. Citations: 02_Panel_Defense_Question_Bank.md Q8a · plan §1 (three-tier CCP) · §2 (9-characteristic rating).</a:t>
+              <a:t>This is the slide the panel uses to decide whether the project deserves capstone status. Concede up front that a trace-capture-plus-LLM-guess wrapper is a weekend's work, then name precisely what such a version would get wrong: no benchmark on unseen architectures, no way to tell a silent failure from a correct answer, no measured false-positive rate on clean controls, no evidence its fix works. Only the 5 strongest characteristics are on-slide, renumbered 1-5 with no gaps. Badge 5 (Ill-defined cause) has three unknowns stacked — read its resolution aloud if pressed: whether/which/what's-correct, each resolved by a distinct pipeline stage. The other 4 (Unfamiliar issues, Significant consequences, Interdependence, Diverse stakeholders) are held back — full reasoning and likely panel questions for all 9 are in markdowns/05-deliverables/defense-prep/CCP_and_Spikes_Full_Reasoning.md, cover them only if asked directly. Citations: 02_Panel_Defense_Question_Bank.md Q8a · plan §1 (three-tier CCP) · §2 (9-characteristic rating).</a:t>
             </a:r>
             <a:endParaRPr lang="en-US" dirty="0"/>
           </a:p>
@@ -9981,40 +9981,139 @@
         </p:nvSpPr>
         <p:spPr>
           <a:xfrm>
-            <a:off x="587045" y="1909267"/>
-            <a:ext cx="3218688" cy="1170432"/>
+            <a:off x="566928" y="1271016"/>
+            <a:ext cx="11057839" cy="896112"/>
           </a:xfrm>
           <a:prstGeom prst="roundRect">
             <a:avLst>
-              <a:gd name="adj" fmla="val 4688"/>
-            </a:avLst>
-          </a:prstGeom>
-          <a:solidFill>
-            <a:srgbClr val="E4E6EB"/>
-          </a:solidFill>
-          <a:ln/>
-        </p:spPr>
-      </p:sp>
-      <p:sp>
-        <p:nvSpPr>
-          <p:cNvPr id="11" name="Shape 9"/>
-          <p:cNvSpPr/>
-          <p:nvPr/>
-        </p:nvSpPr>
-        <p:spPr>
-          <a:xfrm>
-            <a:off x="566928" y="1883664"/>
-            <a:ext cx="3218688" cy="1170432"/>
-          </a:xfrm>
-          <a:prstGeom prst="roundRect">
-            <a:avLst>
-              <a:gd name="adj" fmla="val 4688"/>
+              <a:gd name="adj" fmla="val 5102"/>
             </a:avLst>
           </a:prstGeom>
           <a:solidFill>
             <a:srgbClr val="E6F1EB"/>
           </a:solidFill>
-          <a:ln w="9525">
+          <a:ln w="12700">
+            <a:solidFill>
+              <a:srgbClr val="1E7A52"/>
+            </a:solidFill>
+            <a:prstDash val="solid"/>
+          </a:ln>
+        </p:spPr>
+      </p:sp>
+      <p:sp>
+        <p:nvSpPr>
+          <p:cNvPr id="11" name="Shape 9"/>
+          <p:cNvSpPr/>
+          <p:nvPr/>
+        </p:nvSpPr>
+        <p:spPr>
+          <a:xfrm>
+            <a:off x="731520" y="1554480"/>
+            <a:ext cx="329184" cy="329184"/>
+          </a:xfrm>
+          <a:prstGeom prst="ellipse">
+            <a:avLst/>
+          </a:prstGeom>
+          <a:solidFill>
+            <a:srgbClr val="1E7A52"/>
+          </a:solidFill>
+          <a:ln/>
+        </p:spPr>
+      </p:sp>
+      <p:sp>
+        <p:nvSpPr>
+          <p:cNvPr id="12" name="Text 10"/>
+          <p:cNvSpPr txBox="1"/>
+          <p:nvPr/>
+        </p:nvSpPr>
+        <p:spPr>
+          <a:xfrm>
+            <a:off x="731520" y="1554480"/>
+            <a:ext cx="329184" cy="329184"/>
+          </a:xfrm>
+          <a:prstGeom prst="rect">
+            <a:avLst/>
+          </a:prstGeom>
+          <a:noFill/>
+          <a:ln/>
+        </p:spPr>
+        <p:txBody>
+          <a:bodyPr wrap="square" lIns="0" tIns="0" rIns="0" bIns="0" rtlCol="0" anchor="ctr"/>
+          <a:lstStyle/>
+          <a:p>
+            <a:pPr algn="ctr" indent="0" marL="0">
+              <a:buNone/>
+            </a:pPr>
+            <a:r>
+              <a:rPr lang="en-US" sz="1450" b="1" dirty="0">
+                <a:solidFill>
+                  <a:srgbClr val="F5F6F8"/>
+                </a:solidFill>
+                <a:latin typeface="Georgia" pitchFamily="34" charset="0"/>
+                <a:ea typeface="Georgia" pitchFamily="34" charset="-122"/>
+                <a:cs typeface="Georgia" pitchFamily="34" charset="-120"/>
+              </a:rPr>
+              <a:t>1</a:t>
+            </a:r>
+            <a:endParaRPr lang="en-US" sz="1450" dirty="0"/>
+          </a:p>
+        </p:txBody>
+      </p:sp>
+      <p:sp>
+        <p:nvSpPr>
+          <p:cNvPr id="13" name="Text 11"/>
+          <p:cNvSpPr txBox="1"/>
+          <p:nvPr/>
+        </p:nvSpPr>
+        <p:spPr>
+          <a:xfrm>
+            <a:off x="1207008" y="1271016"/>
+            <a:ext cx="2194560" cy="896112"/>
+          </a:xfrm>
+          <a:prstGeom prst="rect">
+            <a:avLst/>
+          </a:prstGeom>
+          <a:noFill/>
+          <a:ln/>
+        </p:spPr>
+        <p:txBody>
+          <a:bodyPr wrap="square" lIns="0" tIns="0" rIns="0" bIns="0" rtlCol="0" anchor="ctr"/>
+          <a:lstStyle/>
+          <a:p>
+            <a:pPr indent="0" marL="0">
+              <a:buNone/>
+            </a:pPr>
+            <a:r>
+              <a:rPr lang="en-US" sz="1600" b="1" dirty="0">
+                <a:solidFill>
+                  <a:srgbClr val="1B202A"/>
+                </a:solidFill>
+                <a:latin typeface="Georgia" pitchFamily="34" charset="0"/>
+                <a:ea typeface="Georgia" pitchFamily="34" charset="-122"/>
+                <a:cs typeface="Georgia" pitchFamily="34" charset="-120"/>
+              </a:rPr>
+              <a:t>Conflicting requirements</a:t>
+            </a:r>
+            <a:endParaRPr lang="en-US" sz="1600" dirty="0"/>
+          </a:p>
+        </p:txBody>
+      </p:sp>
+      <p:sp>
+        <p:nvSpPr>
+          <p:cNvPr id="14" name="Shape 12"/>
+          <p:cNvSpPr/>
+          <p:nvPr/>
+        </p:nvSpPr>
+        <p:spPr>
+          <a:xfrm>
+            <a:off x="3493008" y="1417320"/>
+            <a:ext cx="0" cy="603504"/>
+          </a:xfrm>
+          <a:prstGeom prst="line">
+            <a:avLst/>
+          </a:prstGeom>
+          <a:noFill/>
+          <a:ln w="12700">
             <a:solidFill>
               <a:srgbClr val="D9DCE3"/>
             </a:solidFill>
@@ -10024,16 +10123,82 @@
       </p:sp>
       <p:sp>
         <p:nvSpPr>
-          <p:cNvPr id="12" name="Shape 10"/>
+          <p:cNvPr id="15" name="Text 13"/>
+          <p:cNvSpPr txBox="1"/>
+          <p:nvPr/>
+        </p:nvSpPr>
+        <p:spPr>
+          <a:xfrm>
+            <a:off x="3694176" y="1271016"/>
+            <a:ext cx="7747711" cy="896112"/>
+          </a:xfrm>
+          <a:prstGeom prst="rect">
+            <a:avLst/>
+          </a:prstGeom>
+          <a:noFill/>
+          <a:ln/>
+        </p:spPr>
+        <p:txBody>
+          <a:bodyPr wrap="square" lIns="0" tIns="0" rIns="0" bIns="0" rtlCol="0" anchor="ctr"/>
+          <a:lstStyle/>
+          <a:p>
+            <a:pPr indent="0" marL="0">
+              <a:buNone/>
+            </a:pPr>
+            <a:r>
+              <a:rPr lang="en-US" sz="1450" dirty="0">
+                <a:solidFill>
+                  <a:srgbClr val="596273"/>
+                </a:solidFill>
+                <a:latin typeface="Calibri" pitchFamily="34" charset="0"/>
+                <a:ea typeface="Calibri" pitchFamily="34" charset="-122"/>
+                <a:cs typeface="Calibri" pitchFamily="34" charset="-120"/>
+              </a:rPr>
+              <a:t>Depth vs. latency; privacy vs. completeness</a:t>
+            </a:r>
+            <a:endParaRPr lang="en-US" sz="1450" dirty="0"/>
+          </a:p>
+        </p:txBody>
+      </p:sp>
+      <p:sp>
+        <p:nvSpPr>
+          <p:cNvPr id="16" name="Shape 14"/>
           <p:cNvSpPr/>
           <p:nvPr/>
         </p:nvSpPr>
         <p:spPr>
           <a:xfrm>
-            <a:off x="566928" y="1938528"/>
-            <a:ext cx="41148" cy="1060704"/>
-          </a:xfrm>
-          <a:prstGeom prst="rect">
+            <a:off x="566928" y="2313432"/>
+            <a:ext cx="11057839" cy="896112"/>
+          </a:xfrm>
+          <a:prstGeom prst="roundRect">
+            <a:avLst>
+              <a:gd name="adj" fmla="val 5102"/>
+            </a:avLst>
+          </a:prstGeom>
+          <a:solidFill>
+            <a:srgbClr val="E6F1EB"/>
+          </a:solidFill>
+          <a:ln w="12700">
+            <a:solidFill>
+              <a:srgbClr val="1E7A52"/>
+            </a:solidFill>
+            <a:prstDash val="solid"/>
+          </a:ln>
+        </p:spPr>
+      </p:sp>
+      <p:sp>
+        <p:nvSpPr>
+          <p:cNvPr id="17" name="Shape 15"/>
+          <p:cNvSpPr/>
+          <p:nvPr/>
+        </p:nvSpPr>
+        <p:spPr>
+          <a:xfrm>
+            <a:off x="731520" y="2596896"/>
+            <a:ext cx="329184" cy="329184"/>
+          </a:xfrm>
+          <a:prstGeom prst="ellipse">
             <a:avLst/>
           </a:prstGeom>
           <a:solidFill>
@@ -10044,34 +10209,14 @@
       </p:sp>
       <p:sp>
         <p:nvSpPr>
-          <p:cNvPr id="13" name="Shape 11"/>
-          <p:cNvSpPr/>
-          <p:nvPr/>
-        </p:nvSpPr>
-        <p:spPr>
-          <a:xfrm>
-            <a:off x="713232" y="2002536"/>
-            <a:ext cx="274320" cy="274320"/>
-          </a:xfrm>
-          <a:prstGeom prst="ellipse">
-            <a:avLst/>
-          </a:prstGeom>
-          <a:solidFill>
-            <a:srgbClr val="1E7A52"/>
-          </a:solidFill>
-          <a:ln/>
-        </p:spPr>
-      </p:sp>
-      <p:sp>
-        <p:nvSpPr>
-          <p:cNvPr id="14" name="Text 12"/>
+          <p:cNvPr id="18" name="Text 16"/>
           <p:cNvSpPr txBox="1"/>
           <p:nvPr/>
         </p:nvSpPr>
         <p:spPr>
           <a:xfrm>
-            <a:off x="713232" y="2002536"/>
-            <a:ext cx="274320" cy="274320"/>
+            <a:off x="731520" y="2596896"/>
+            <a:ext cx="329184" cy="329184"/>
           </a:xfrm>
           <a:prstGeom prst="rect">
             <a:avLst/>
@@ -10095,7 +10240,7 @@
                 <a:ea typeface="Georgia" pitchFamily="34" charset="-122"/>
                 <a:cs typeface="Georgia" pitchFamily="34" charset="-120"/>
               </a:rPr>
-              <a:t>1</a:t>
+              <a:t>2</a:t>
             </a:r>
             <a:endParaRPr lang="en-US" sz="1450" dirty="0"/>
           </a:p>
@@ -10103,14 +10248,14 @@
       </p:sp>
       <p:sp>
         <p:nvSpPr>
-          <p:cNvPr id="15" name="Text 13"/>
+          <p:cNvPr id="19" name="Text 17"/>
           <p:cNvSpPr txBox="1"/>
           <p:nvPr/>
         </p:nvSpPr>
         <p:spPr>
           <a:xfrm>
-            <a:off x="1078992" y="1984248"/>
-            <a:ext cx="2596896" cy="329184"/>
+            <a:off x="1207008" y="2313432"/>
+            <a:ext cx="2194560" cy="896112"/>
           </a:xfrm>
           <a:prstGeom prst="rect">
             <a:avLst/>
@@ -10126,7 +10271,7 @@
               <a:buNone/>
             </a:pPr>
             <a:r>
-              <a:rPr lang="en-US" sz="1400" b="1" dirty="0">
+              <a:rPr lang="en-US" sz="1600" b="1" dirty="0">
                 <a:solidFill>
                   <a:srgbClr val="1B202A"/>
                 </a:solidFill>
@@ -10134,93 +10279,28 @@
                 <a:ea typeface="Georgia" pitchFamily="34" charset="-122"/>
                 <a:cs typeface="Georgia" pitchFamily="34" charset="-120"/>
               </a:rPr>
-              <a:t>Conflicting requirements</a:t>
-            </a:r>
-            <a:endParaRPr lang="en-US" sz="1400" dirty="0"/>
+              <a:t>No obvious solution</a:t>
+            </a:r>
+            <a:endParaRPr lang="en-US" sz="1600" dirty="0"/>
           </a:p>
         </p:txBody>
       </p:sp>
       <p:sp>
         <p:nvSpPr>
-          <p:cNvPr id="16" name="Text 14"/>
-          <p:cNvSpPr txBox="1"/>
-          <p:nvPr/>
-        </p:nvSpPr>
-        <p:spPr>
-          <a:xfrm>
-            <a:off x="713232" y="2322576"/>
-            <a:ext cx="2944368" cy="676656"/>
-          </a:xfrm>
-          <a:prstGeom prst="rect">
-            <a:avLst/>
-          </a:prstGeom>
-          <a:noFill/>
-          <a:ln/>
-        </p:spPr>
-        <p:txBody>
-          <a:bodyPr wrap="square" lIns="0" tIns="0" rIns="0" bIns="0" rtlCol="0" anchor="ctr"/>
-          <a:lstStyle/>
-          <a:p>
-            <a:pPr indent="0" marL="0">
-              <a:buNone/>
-            </a:pPr>
-            <a:r>
-              <a:rPr lang="en-US" sz="1150" dirty="0">
-                <a:solidFill>
-                  <a:srgbClr val="596273"/>
-                </a:solidFill>
-                <a:latin typeface="Calibri" pitchFamily="34" charset="0"/>
-                <a:ea typeface="Calibri" pitchFamily="34" charset="-122"/>
-                <a:cs typeface="Calibri" pitchFamily="34" charset="-120"/>
-              </a:rPr>
-              <a:t>Depth vs. latency; privacy vs. completeness</a:t>
-            </a:r>
-            <a:endParaRPr lang="en-US" sz="1150" dirty="0"/>
-          </a:p>
-        </p:txBody>
-      </p:sp>
-      <p:sp>
-        <p:nvSpPr>
-          <p:cNvPr id="17" name="Shape 15"/>
+          <p:cNvPr id="20" name="Shape 18"/>
           <p:cNvSpPr/>
           <p:nvPr/>
         </p:nvSpPr>
         <p:spPr>
           <a:xfrm>
-            <a:off x="3970325" y="1909267"/>
-            <a:ext cx="3218688" cy="1170432"/>
-          </a:xfrm>
-          <a:prstGeom prst="roundRect">
-            <a:avLst>
-              <a:gd name="adj" fmla="val 4688"/>
-            </a:avLst>
-          </a:prstGeom>
-          <a:solidFill>
-            <a:srgbClr val="E4E6EB"/>
-          </a:solidFill>
-          <a:ln/>
-        </p:spPr>
-      </p:sp>
-      <p:sp>
-        <p:nvSpPr>
-          <p:cNvPr id="18" name="Shape 16"/>
-          <p:cNvSpPr/>
-          <p:nvPr/>
-        </p:nvSpPr>
-        <p:spPr>
-          <a:xfrm>
-            <a:off x="3950208" y="1883664"/>
-            <a:ext cx="3218688" cy="1170432"/>
-          </a:xfrm>
-          <a:prstGeom prst="roundRect">
-            <a:avLst>
-              <a:gd name="adj" fmla="val 4688"/>
-            </a:avLst>
-          </a:prstGeom>
-          <a:solidFill>
-            <a:srgbClr val="E6F1EB"/>
-          </a:solidFill>
-          <a:ln w="9525">
+            <a:off x="3493008" y="2459736"/>
+            <a:ext cx="0" cy="603504"/>
+          </a:xfrm>
+          <a:prstGeom prst="line">
+            <a:avLst/>
+          </a:prstGeom>
+          <a:noFill/>
+          <a:ln w="12700">
             <a:solidFill>
               <a:srgbClr val="D9DCE3"/>
             </a:solidFill>
@@ -10230,16 +10310,82 @@
       </p:sp>
       <p:sp>
         <p:nvSpPr>
-          <p:cNvPr id="19" name="Shape 17"/>
+          <p:cNvPr id="21" name="Text 19"/>
+          <p:cNvSpPr txBox="1"/>
+          <p:nvPr/>
+        </p:nvSpPr>
+        <p:spPr>
+          <a:xfrm>
+            <a:off x="3694176" y="2313432"/>
+            <a:ext cx="7747711" cy="896112"/>
+          </a:xfrm>
+          <a:prstGeom prst="rect">
+            <a:avLst/>
+          </a:prstGeom>
+          <a:noFill/>
+          <a:ln/>
+        </p:spPr>
+        <p:txBody>
+          <a:bodyPr wrap="square" lIns="0" tIns="0" rIns="0" bIns="0" rtlCol="0" anchor="ctr"/>
+          <a:lstStyle/>
+          <a:p>
+            <a:pPr indent="0" marL="0">
+              <a:buNone/>
+            </a:pPr>
+            <a:r>
+              <a:rPr lang="en-US" sz="1450" dirty="0">
+                <a:solidFill>
+                  <a:srgbClr val="596273"/>
+                </a:solidFill>
+                <a:latin typeface="Calibri" pitchFamily="34" charset="0"/>
+                <a:ea typeface="Calibri" pitchFamily="34" charset="-122"/>
+                <a:cs typeface="Calibri" pitchFamily="34" charset="-120"/>
+              </a:rPr>
+              <a:t>Best published: 59.5% after 15 months, 7 papers</a:t>
+            </a:r>
+            <a:endParaRPr lang="en-US" sz="1450" dirty="0"/>
+          </a:p>
+        </p:txBody>
+      </p:sp>
+      <p:sp>
+        <p:nvSpPr>
+          <p:cNvPr id="22" name="Shape 20"/>
           <p:cNvSpPr/>
           <p:nvPr/>
         </p:nvSpPr>
         <p:spPr>
           <a:xfrm>
-            <a:off x="3950208" y="1938528"/>
-            <a:ext cx="41148" cy="1060704"/>
-          </a:xfrm>
-          <a:prstGeom prst="rect">
+            <a:off x="566928" y="3355848"/>
+            <a:ext cx="11057839" cy="896112"/>
+          </a:xfrm>
+          <a:prstGeom prst="roundRect">
+            <a:avLst>
+              <a:gd name="adj" fmla="val 5102"/>
+            </a:avLst>
+          </a:prstGeom>
+          <a:solidFill>
+            <a:srgbClr val="E6F1EB"/>
+          </a:solidFill>
+          <a:ln w="12700">
+            <a:solidFill>
+              <a:srgbClr val="1E7A52"/>
+            </a:solidFill>
+            <a:prstDash val="solid"/>
+          </a:ln>
+        </p:spPr>
+      </p:sp>
+      <p:sp>
+        <p:nvSpPr>
+          <p:cNvPr id="23" name="Shape 21"/>
+          <p:cNvSpPr/>
+          <p:nvPr/>
+        </p:nvSpPr>
+        <p:spPr>
+          <a:xfrm>
+            <a:off x="731520" y="3639312"/>
+            <a:ext cx="329184" cy="329184"/>
+          </a:xfrm>
+          <a:prstGeom prst="ellipse">
             <a:avLst/>
           </a:prstGeom>
           <a:solidFill>
@@ -10250,34 +10396,14 @@
       </p:sp>
       <p:sp>
         <p:nvSpPr>
-          <p:cNvPr id="20" name="Shape 18"/>
-          <p:cNvSpPr/>
-          <p:nvPr/>
-        </p:nvSpPr>
-        <p:spPr>
-          <a:xfrm>
-            <a:off x="4096512" y="2002536"/>
-            <a:ext cx="274320" cy="274320"/>
-          </a:xfrm>
-          <a:prstGeom prst="ellipse">
-            <a:avLst/>
-          </a:prstGeom>
-          <a:solidFill>
-            <a:srgbClr val="1E7A52"/>
-          </a:solidFill>
-          <a:ln/>
-        </p:spPr>
-      </p:sp>
-      <p:sp>
-        <p:nvSpPr>
-          <p:cNvPr id="21" name="Text 19"/>
+          <p:cNvPr id="24" name="Text 22"/>
           <p:cNvSpPr txBox="1"/>
           <p:nvPr/>
         </p:nvSpPr>
         <p:spPr>
           <a:xfrm>
-            <a:off x="4096512" y="2002536"/>
-            <a:ext cx="274320" cy="274320"/>
+            <a:off x="731520" y="3639312"/>
+            <a:ext cx="329184" cy="329184"/>
           </a:xfrm>
           <a:prstGeom prst="rect">
             <a:avLst/>
@@ -10301,7 +10427,7 @@
                 <a:ea typeface="Georgia" pitchFamily="34" charset="-122"/>
                 <a:cs typeface="Georgia" pitchFamily="34" charset="-120"/>
               </a:rPr>
-              <a:t>2</a:t>
+              <a:t>3</a:t>
             </a:r>
             <a:endParaRPr lang="en-US" sz="1450" dirty="0"/>
           </a:p>
@@ -10309,14 +10435,14 @@
       </p:sp>
       <p:sp>
         <p:nvSpPr>
-          <p:cNvPr id="22" name="Text 20"/>
+          <p:cNvPr id="25" name="Text 23"/>
           <p:cNvSpPr txBox="1"/>
           <p:nvPr/>
         </p:nvSpPr>
         <p:spPr>
           <a:xfrm>
-            <a:off x="4462272" y="1984248"/>
-            <a:ext cx="2596896" cy="329184"/>
+            <a:off x="1207008" y="3355848"/>
+            <a:ext cx="2194560" cy="896112"/>
           </a:xfrm>
           <a:prstGeom prst="rect">
             <a:avLst/>
@@ -10332,7 +10458,7 @@
               <a:buNone/>
             </a:pPr>
             <a:r>
-              <a:rPr lang="en-US" sz="1400" b="1" dirty="0">
+              <a:rPr lang="en-US" sz="1600" b="1" dirty="0">
                 <a:solidFill>
                   <a:srgbClr val="1B202A"/>
                 </a:solidFill>
@@ -10340,93 +10466,28 @@
                 <a:ea typeface="Georgia" pitchFamily="34" charset="-122"/>
                 <a:cs typeface="Georgia" pitchFamily="34" charset="-120"/>
               </a:rPr>
-              <a:t>No obvious solution</a:t>
-            </a:r>
-            <a:endParaRPr lang="en-US" sz="1400" dirty="0"/>
+              <a:t>Depth of knowledge</a:t>
+            </a:r>
+            <a:endParaRPr lang="en-US" sz="1600" dirty="0"/>
           </a:p>
         </p:txBody>
       </p:sp>
       <p:sp>
         <p:nvSpPr>
-          <p:cNvPr id="23" name="Text 21"/>
-          <p:cNvSpPr txBox="1"/>
-          <p:nvPr/>
-        </p:nvSpPr>
-        <p:spPr>
-          <a:xfrm>
-            <a:off x="4096512" y="2322576"/>
-            <a:ext cx="2944368" cy="676656"/>
-          </a:xfrm>
-          <a:prstGeom prst="rect">
-            <a:avLst/>
-          </a:prstGeom>
-          <a:noFill/>
-          <a:ln/>
-        </p:spPr>
-        <p:txBody>
-          <a:bodyPr wrap="square" lIns="0" tIns="0" rIns="0" bIns="0" rtlCol="0" anchor="ctr"/>
-          <a:lstStyle/>
-          <a:p>
-            <a:pPr indent="0" marL="0">
-              <a:buNone/>
-            </a:pPr>
-            <a:r>
-              <a:rPr lang="en-US" sz="1150" dirty="0">
-                <a:solidFill>
-                  <a:srgbClr val="596273"/>
-                </a:solidFill>
-                <a:latin typeface="Calibri" pitchFamily="34" charset="0"/>
-                <a:ea typeface="Calibri" pitchFamily="34" charset="-122"/>
-                <a:cs typeface="Calibri" pitchFamily="34" charset="-120"/>
-              </a:rPr>
-              <a:t>Best published: 59.5% after 15 months, 7 papers</a:t>
-            </a:r>
-            <a:endParaRPr lang="en-US" sz="1150" dirty="0"/>
-          </a:p>
-        </p:txBody>
-      </p:sp>
-      <p:sp>
-        <p:nvSpPr>
-          <p:cNvPr id="24" name="Shape 22"/>
+          <p:cNvPr id="26" name="Shape 24"/>
           <p:cNvSpPr/>
           <p:nvPr/>
         </p:nvSpPr>
         <p:spPr>
           <a:xfrm>
-            <a:off x="587045" y="3189427"/>
-            <a:ext cx="3218688" cy="1170432"/>
-          </a:xfrm>
-          <a:prstGeom prst="roundRect">
-            <a:avLst>
-              <a:gd name="adj" fmla="val 4688"/>
-            </a:avLst>
-          </a:prstGeom>
-          <a:solidFill>
-            <a:srgbClr val="E4E6EB"/>
-          </a:solidFill>
-          <a:ln/>
-        </p:spPr>
-      </p:sp>
-      <p:sp>
-        <p:nvSpPr>
-          <p:cNvPr id="25" name="Shape 23"/>
-          <p:cNvSpPr/>
-          <p:nvPr/>
-        </p:nvSpPr>
-        <p:spPr>
-          <a:xfrm>
-            <a:off x="566928" y="3163824"/>
-            <a:ext cx="3218688" cy="1170432"/>
-          </a:xfrm>
-          <a:prstGeom prst="roundRect">
-            <a:avLst>
-              <a:gd name="adj" fmla="val 4688"/>
-            </a:avLst>
-          </a:prstGeom>
-          <a:solidFill>
-            <a:srgbClr val="E6F1EB"/>
-          </a:solidFill>
-          <a:ln w="9525">
+            <a:off x="3493008" y="3502152"/>
+            <a:ext cx="0" cy="603504"/>
+          </a:xfrm>
+          <a:prstGeom prst="line">
+            <a:avLst/>
+          </a:prstGeom>
+          <a:noFill/>
+          <a:ln w="12700">
             <a:solidFill>
               <a:srgbClr val="D9DCE3"/>
             </a:solidFill>
@@ -10436,16 +10497,82 @@
       </p:sp>
       <p:sp>
         <p:nvSpPr>
-          <p:cNvPr id="26" name="Shape 24"/>
+          <p:cNvPr id="27" name="Text 25"/>
+          <p:cNvSpPr txBox="1"/>
+          <p:nvPr/>
+        </p:nvSpPr>
+        <p:spPr>
+          <a:xfrm>
+            <a:off x="3694176" y="3355848"/>
+            <a:ext cx="7747711" cy="896112"/>
+          </a:xfrm>
+          <a:prstGeom prst="rect">
+            <a:avLst/>
+          </a:prstGeom>
+          <a:noFill/>
+          <a:ln/>
+        </p:spPr>
+        <p:txBody>
+          <a:bodyPr wrap="square" lIns="0" tIns="0" rIns="0" bIns="0" rtlCol="0" anchor="ctr"/>
+          <a:lstStyle/>
+          <a:p>
+            <a:pPr indent="0" marL="0">
+              <a:buNone/>
+            </a:pPr>
+            <a:r>
+              <a:rPr lang="en-US" sz="1450" dirty="0">
+                <a:solidFill>
+                  <a:srgbClr val="596273"/>
+                </a:solidFill>
+                <a:latin typeface="Calibri" pitchFamily="34" charset="0"/>
+                <a:ea typeface="Calibri" pitchFamily="34" charset="-122"/>
+                <a:cs typeface="Calibri" pitchFamily="34" charset="-120"/>
+              </a:rPr>
+              <a:t>Graph modeling, causal reasoning, tracing</a:t>
+            </a:r>
+            <a:endParaRPr lang="en-US" sz="1450" dirty="0"/>
+          </a:p>
+        </p:txBody>
+      </p:sp>
+      <p:sp>
+        <p:nvSpPr>
+          <p:cNvPr id="28" name="Shape 26"/>
           <p:cNvSpPr/>
           <p:nvPr/>
         </p:nvSpPr>
         <p:spPr>
           <a:xfrm>
-            <a:off x="566928" y="3218688"/>
-            <a:ext cx="41148" cy="1060704"/>
-          </a:xfrm>
-          <a:prstGeom prst="rect">
+            <a:off x="566928" y="4398264"/>
+            <a:ext cx="11057839" cy="896112"/>
+          </a:xfrm>
+          <a:prstGeom prst="roundRect">
+            <a:avLst>
+              <a:gd name="adj" fmla="val 5102"/>
+            </a:avLst>
+          </a:prstGeom>
+          <a:solidFill>
+            <a:srgbClr val="E6F1EB"/>
+          </a:solidFill>
+          <a:ln w="12700">
+            <a:solidFill>
+              <a:srgbClr val="1E7A52"/>
+            </a:solidFill>
+            <a:prstDash val="solid"/>
+          </a:ln>
+        </p:spPr>
+      </p:sp>
+      <p:sp>
+        <p:nvSpPr>
+          <p:cNvPr id="29" name="Shape 27"/>
+          <p:cNvSpPr/>
+          <p:nvPr/>
+        </p:nvSpPr>
+        <p:spPr>
+          <a:xfrm>
+            <a:off x="731520" y="4681728"/>
+            <a:ext cx="329184" cy="329184"/>
+          </a:xfrm>
+          <a:prstGeom prst="ellipse">
             <a:avLst/>
           </a:prstGeom>
           <a:solidFill>
@@ -10456,34 +10583,14 @@
       </p:sp>
       <p:sp>
         <p:nvSpPr>
-          <p:cNvPr id="27" name="Shape 25"/>
-          <p:cNvSpPr/>
-          <p:nvPr/>
-        </p:nvSpPr>
-        <p:spPr>
-          <a:xfrm>
-            <a:off x="713232" y="3282696"/>
-            <a:ext cx="274320" cy="274320"/>
-          </a:xfrm>
-          <a:prstGeom prst="ellipse">
-            <a:avLst/>
-          </a:prstGeom>
-          <a:solidFill>
-            <a:srgbClr val="1E7A52"/>
-          </a:solidFill>
-          <a:ln/>
-        </p:spPr>
-      </p:sp>
-      <p:sp>
-        <p:nvSpPr>
-          <p:cNvPr id="28" name="Text 26"/>
+          <p:cNvPr id="30" name="Text 28"/>
           <p:cNvSpPr txBox="1"/>
           <p:nvPr/>
         </p:nvSpPr>
         <p:spPr>
           <a:xfrm>
-            <a:off x="713232" y="3282696"/>
-            <a:ext cx="274320" cy="274320"/>
+            <a:off x="731520" y="4681728"/>
+            <a:ext cx="329184" cy="329184"/>
           </a:xfrm>
           <a:prstGeom prst="rect">
             <a:avLst/>
@@ -10507,7 +10614,7 @@
                 <a:ea typeface="Georgia" pitchFamily="34" charset="-122"/>
                 <a:cs typeface="Georgia" pitchFamily="34" charset="-120"/>
               </a:rPr>
-              <a:t>3</a:t>
+              <a:t>4</a:t>
             </a:r>
             <a:endParaRPr lang="en-US" sz="1450" dirty="0"/>
           </a:p>
@@ -10515,14 +10622,14 @@
       </p:sp>
       <p:sp>
         <p:nvSpPr>
-          <p:cNvPr id="29" name="Text 27"/>
+          <p:cNvPr id="31" name="Text 29"/>
           <p:cNvSpPr txBox="1"/>
           <p:nvPr/>
         </p:nvSpPr>
         <p:spPr>
           <a:xfrm>
-            <a:off x="1078992" y="3264408"/>
-            <a:ext cx="2596896" cy="329184"/>
+            <a:off x="1207008" y="4398264"/>
+            <a:ext cx="2194560" cy="896112"/>
           </a:xfrm>
           <a:prstGeom prst="rect">
             <a:avLst/>
@@ -10538,7 +10645,7 @@
               <a:buNone/>
             </a:pPr>
             <a:r>
-              <a:rPr lang="en-US" sz="1400" b="1" dirty="0">
+              <a:rPr lang="en-US" sz="1600" b="1" dirty="0">
                 <a:solidFill>
                   <a:srgbClr val="1B202A"/>
                 </a:solidFill>
@@ -10546,72 +10653,11 @@
                 <a:ea typeface="Georgia" pitchFamily="34" charset="-122"/>
                 <a:cs typeface="Georgia" pitchFamily="34" charset="-120"/>
               </a:rPr>
-              <a:t>Depth of knowledge</a:t>
-            </a:r>
-            <a:endParaRPr lang="en-US" sz="1400" dirty="0"/>
+              <a:t>Beyond standard practice</a:t>
+            </a:r>
+            <a:endParaRPr lang="en-US" sz="1600" dirty="0"/>
           </a:p>
         </p:txBody>
-      </p:sp>
-      <p:sp>
-        <p:nvSpPr>
-          <p:cNvPr id="30" name="Text 28"/>
-          <p:cNvSpPr txBox="1"/>
-          <p:nvPr/>
-        </p:nvSpPr>
-        <p:spPr>
-          <a:xfrm>
-            <a:off x="713232" y="3602736"/>
-            <a:ext cx="2944368" cy="676656"/>
-          </a:xfrm>
-          <a:prstGeom prst="rect">
-            <a:avLst/>
-          </a:prstGeom>
-          <a:noFill/>
-          <a:ln/>
-        </p:spPr>
-        <p:txBody>
-          <a:bodyPr wrap="square" lIns="0" tIns="0" rIns="0" bIns="0" rtlCol="0" anchor="ctr"/>
-          <a:lstStyle/>
-          <a:p>
-            <a:pPr indent="0" marL="0">
-              <a:buNone/>
-            </a:pPr>
-            <a:r>
-              <a:rPr lang="en-US" sz="1150" dirty="0">
-                <a:solidFill>
-                  <a:srgbClr val="596273"/>
-                </a:solidFill>
-                <a:latin typeface="Calibri" pitchFamily="34" charset="0"/>
-                <a:ea typeface="Calibri" pitchFamily="34" charset="-122"/>
-                <a:cs typeface="Calibri" pitchFamily="34" charset="-120"/>
-              </a:rPr>
-              <a:t>Graph modeling, causal reasoning, tracing</a:t>
-            </a:r>
-            <a:endParaRPr lang="en-US" sz="1150" dirty="0"/>
-          </a:p>
-        </p:txBody>
-      </p:sp>
-      <p:sp>
-        <p:nvSpPr>
-          <p:cNvPr id="31" name="Shape 29"/>
-          <p:cNvSpPr/>
-          <p:nvPr/>
-        </p:nvSpPr>
-        <p:spPr>
-          <a:xfrm>
-            <a:off x="3970325" y="3189427"/>
-            <a:ext cx="3218688" cy="1170432"/>
-          </a:xfrm>
-          <a:prstGeom prst="roundRect">
-            <a:avLst>
-              <a:gd name="adj" fmla="val 4688"/>
-            </a:avLst>
-          </a:prstGeom>
-          <a:solidFill>
-            <a:srgbClr val="E4E6EB"/>
-          </a:solidFill>
-          <a:ln/>
-        </p:spPr>
       </p:sp>
       <p:sp>
         <p:nvSpPr>
@@ -10621,18 +10667,14 @@
         </p:nvSpPr>
         <p:spPr>
           <a:xfrm>
-            <a:off x="3950208" y="3163824"/>
-            <a:ext cx="3218688" cy="1170432"/>
-          </a:xfrm>
-          <a:prstGeom prst="roundRect">
-            <a:avLst>
-              <a:gd name="adj" fmla="val 4688"/>
-            </a:avLst>
-          </a:prstGeom>
-          <a:solidFill>
-            <a:srgbClr val="F7EFDC"/>
-          </a:solidFill>
-          <a:ln w="9525">
+            <a:off x="3493008" y="4544568"/>
+            <a:ext cx="0" cy="603504"/>
+          </a:xfrm>
+          <a:prstGeom prst="line">
+            <a:avLst/>
+          </a:prstGeom>
+          <a:noFill/>
+          <a:ln w="12700">
             <a:solidFill>
               <a:srgbClr val="D9DCE3"/>
             </a:solidFill>
@@ -10642,54 +10684,14 @@
       </p:sp>
       <p:sp>
         <p:nvSpPr>
-          <p:cNvPr id="33" name="Shape 31"/>
-          <p:cNvSpPr/>
-          <p:nvPr/>
-        </p:nvSpPr>
-        <p:spPr>
-          <a:xfrm>
-            <a:off x="3950208" y="3218688"/>
-            <a:ext cx="41148" cy="1060704"/>
-          </a:xfrm>
-          <a:prstGeom prst="rect">
-            <a:avLst/>
-          </a:prstGeom>
-          <a:solidFill>
-            <a:srgbClr val="A8760F"/>
-          </a:solidFill>
-          <a:ln/>
-        </p:spPr>
-      </p:sp>
-      <p:sp>
-        <p:nvSpPr>
-          <p:cNvPr id="34" name="Shape 32"/>
-          <p:cNvSpPr/>
-          <p:nvPr/>
-        </p:nvSpPr>
-        <p:spPr>
-          <a:xfrm>
-            <a:off x="4096512" y="3282696"/>
-            <a:ext cx="274320" cy="274320"/>
-          </a:xfrm>
-          <a:prstGeom prst="ellipse">
-            <a:avLst/>
-          </a:prstGeom>
-          <a:solidFill>
-            <a:srgbClr val="A8760F"/>
-          </a:solidFill>
-          <a:ln/>
-        </p:spPr>
-      </p:sp>
-      <p:sp>
-        <p:nvSpPr>
-          <p:cNvPr id="35" name="Text 33"/>
+          <p:cNvPr id="33" name="Text 31"/>
           <p:cNvSpPr txBox="1"/>
           <p:nvPr/>
         </p:nvSpPr>
         <p:spPr>
           <a:xfrm>
-            <a:off x="4096512" y="3282696"/>
-            <a:ext cx="274320" cy="274320"/>
+            <a:off x="3694176" y="4398264"/>
+            <a:ext cx="7747711" cy="896112"/>
           </a:xfrm>
           <a:prstGeom prst="rect">
             <a:avLst/>
@@ -10701,6 +10703,92 @@
           <a:bodyPr wrap="square" lIns="0" tIns="0" rIns="0" bIns="0" rtlCol="0" anchor="ctr"/>
           <a:lstStyle/>
           <a:p>
+            <a:pPr indent="0" marL="0">
+              <a:buNone/>
+            </a:pPr>
+            <a:r>
+              <a:rPr lang="en-US" sz="1450" dirty="0">
+                <a:solidFill>
+                  <a:srgbClr val="596273"/>
+                </a:solidFill>
+                <a:latin typeface="Calibri" pitchFamily="34" charset="0"/>
+                <a:ea typeface="Calibri" pitchFamily="34" charset="-122"/>
+                <a:cs typeface="Calibri" pitchFamily="34" charset="-120"/>
+              </a:rPr>
+              <a:t>No framework does attribution + detection + recovery</a:t>
+            </a:r>
+            <a:endParaRPr lang="en-US" sz="1450" dirty="0"/>
+          </a:p>
+        </p:txBody>
+      </p:sp>
+      <p:sp>
+        <p:nvSpPr>
+          <p:cNvPr id="34" name="Shape 32"/>
+          <p:cNvSpPr/>
+          <p:nvPr/>
+        </p:nvSpPr>
+        <p:spPr>
+          <a:xfrm>
+            <a:off x="566928" y="5440680"/>
+            <a:ext cx="11057839" cy="896112"/>
+          </a:xfrm>
+          <a:prstGeom prst="roundRect">
+            <a:avLst>
+              <a:gd name="adj" fmla="val 5102"/>
+            </a:avLst>
+          </a:prstGeom>
+          <a:solidFill>
+            <a:srgbClr val="E6F1EB"/>
+          </a:solidFill>
+          <a:ln w="12700">
+            <a:solidFill>
+              <a:srgbClr val="1E7A52"/>
+            </a:solidFill>
+            <a:prstDash val="solid"/>
+          </a:ln>
+        </p:spPr>
+      </p:sp>
+      <p:sp>
+        <p:nvSpPr>
+          <p:cNvPr id="35" name="Shape 33"/>
+          <p:cNvSpPr/>
+          <p:nvPr/>
+        </p:nvSpPr>
+        <p:spPr>
+          <a:xfrm>
+            <a:off x="731520" y="5724144"/>
+            <a:ext cx="329184" cy="329184"/>
+          </a:xfrm>
+          <a:prstGeom prst="ellipse">
+            <a:avLst/>
+          </a:prstGeom>
+          <a:solidFill>
+            <a:srgbClr val="1E7A52"/>
+          </a:solidFill>
+          <a:ln/>
+        </p:spPr>
+      </p:sp>
+      <p:sp>
+        <p:nvSpPr>
+          <p:cNvPr id="36" name="Text 34"/>
+          <p:cNvSpPr txBox="1"/>
+          <p:nvPr/>
+        </p:nvSpPr>
+        <p:spPr>
+          <a:xfrm>
+            <a:off x="731520" y="5724144"/>
+            <a:ext cx="329184" cy="329184"/>
+          </a:xfrm>
+          <a:prstGeom prst="rect">
+            <a:avLst/>
+          </a:prstGeom>
+          <a:noFill/>
+          <a:ln/>
+        </p:spPr>
+        <p:txBody>
+          <a:bodyPr wrap="square" lIns="0" tIns="0" rIns="0" bIns="0" rtlCol="0" anchor="ctr"/>
+          <a:lstStyle/>
+          <a:p>
             <a:pPr algn="ctr" indent="0" marL="0">
               <a:buNone/>
             </a:pPr>
@@ -10713,7 +10801,7 @@
                 <a:ea typeface="Georgia" pitchFamily="34" charset="-122"/>
                 <a:cs typeface="Georgia" pitchFamily="34" charset="-120"/>
               </a:rPr>
-              <a:t>4</a:t>
+              <a:t>5</a:t>
             </a:r>
             <a:endParaRPr lang="en-US" sz="1450" dirty="0"/>
           </a:p>
@@ -10721,14 +10809,14 @@
       </p:sp>
       <p:sp>
         <p:nvSpPr>
-          <p:cNvPr id="36" name="Text 34"/>
+          <p:cNvPr id="37" name="Text 35"/>
           <p:cNvSpPr txBox="1"/>
           <p:nvPr/>
         </p:nvSpPr>
         <p:spPr>
           <a:xfrm>
-            <a:off x="4462272" y="3264408"/>
-            <a:ext cx="2596896" cy="329184"/>
+            <a:off x="1207008" y="5440680"/>
+            <a:ext cx="2194560" cy="896112"/>
           </a:xfrm>
           <a:prstGeom prst="rect">
             <a:avLst/>
@@ -10744,7 +10832,7 @@
               <a:buNone/>
             </a:pPr>
             <a:r>
-              <a:rPr lang="en-US" sz="1400" b="1" dirty="0">
+              <a:rPr lang="en-US" sz="1600" b="1" dirty="0">
                 <a:solidFill>
                   <a:srgbClr val="1B202A"/>
                 </a:solidFill>
@@ -10752,48 +10840,9 @@
                 <a:ea typeface="Georgia" pitchFamily="34" charset="-122"/>
                 <a:cs typeface="Georgia" pitchFamily="34" charset="-120"/>
               </a:rPr>
-              <a:t>Diverse stakeholders</a:t>
-            </a:r>
-            <a:endParaRPr lang="en-US" sz="1400" dirty="0"/>
-          </a:p>
-        </p:txBody>
-      </p:sp>
-      <p:sp>
-        <p:nvSpPr>
-          <p:cNvPr id="37" name="Text 35"/>
-          <p:cNvSpPr txBox="1"/>
-          <p:nvPr/>
-        </p:nvSpPr>
-        <p:spPr>
-          <a:xfrm>
-            <a:off x="4096512" y="3602736"/>
-            <a:ext cx="2944368" cy="676656"/>
-          </a:xfrm>
-          <a:prstGeom prst="rect">
-            <a:avLst/>
-          </a:prstGeom>
-          <a:noFill/>
-          <a:ln/>
-        </p:spPr>
-        <p:txBody>
-          <a:bodyPr wrap="square" lIns="0" tIns="0" rIns="0" bIns="0" rtlCol="0" anchor="ctr"/>
-          <a:lstStyle/>
-          <a:p>
-            <a:pPr indent="0" marL="0">
-              <a:buNone/>
-            </a:pPr>
-            <a:r>
-              <a:rPr lang="en-US" sz="1150" dirty="0">
-                <a:solidFill>
-                  <a:srgbClr val="596273"/>
-                </a:solidFill>
-                <a:latin typeface="Calibri" pitchFamily="34" charset="0"/>
-                <a:ea typeface="Calibri" pitchFamily="34" charset="-122"/>
-                <a:cs typeface="Calibri" pitchFamily="34" charset="-120"/>
-              </a:rPr>
-              <a:t>Named; live contact scheduled Mid-2</a:t>
-            </a:r>
-            <a:endParaRPr lang="en-US" sz="1150" dirty="0"/>
+              <a:t>Ill-defined cause</a:t>
+            </a:r>
+            <a:endParaRPr lang="en-US" sz="1600" dirty="0"/>
           </a:p>
         </p:txBody>
       </p:sp>
@@ -10805,40 +10854,14 @@
         </p:nvSpPr>
         <p:spPr>
           <a:xfrm>
-            <a:off x="587045" y="4469587"/>
-            <a:ext cx="3218688" cy="1170432"/>
-          </a:xfrm>
-          <a:prstGeom prst="roundRect">
-            <a:avLst>
-              <a:gd name="adj" fmla="val 4688"/>
-            </a:avLst>
-          </a:prstGeom>
-          <a:solidFill>
-            <a:srgbClr val="E4E6EB"/>
-          </a:solidFill>
-          <a:ln/>
-        </p:spPr>
-      </p:sp>
-      <p:sp>
-        <p:nvSpPr>
-          <p:cNvPr id="39" name="Shape 37"/>
-          <p:cNvSpPr/>
-          <p:nvPr/>
-        </p:nvSpPr>
-        <p:spPr>
-          <a:xfrm>
-            <a:off x="566928" y="4443984"/>
-            <a:ext cx="3218688" cy="1170432"/>
-          </a:xfrm>
-          <a:prstGeom prst="roundRect">
-            <a:avLst>
-              <a:gd name="adj" fmla="val 4688"/>
-            </a:avLst>
-          </a:prstGeom>
-          <a:solidFill>
-            <a:srgbClr val="E6F1EB"/>
-          </a:solidFill>
-          <a:ln w="9525">
+            <a:off x="3493008" y="5586984"/>
+            <a:ext cx="0" cy="603504"/>
+          </a:xfrm>
+          <a:prstGeom prst="line">
+            <a:avLst/>
+          </a:prstGeom>
+          <a:noFill/>
+          <a:ln w="12700">
             <a:solidFill>
               <a:srgbClr val="D9DCE3"/>
             </a:solidFill>
@@ -10848,54 +10871,14 @@
       </p:sp>
       <p:sp>
         <p:nvSpPr>
-          <p:cNvPr id="40" name="Shape 38"/>
-          <p:cNvSpPr/>
-          <p:nvPr/>
-        </p:nvSpPr>
-        <p:spPr>
-          <a:xfrm>
-            <a:off x="566928" y="4498848"/>
-            <a:ext cx="41148" cy="1060704"/>
-          </a:xfrm>
-          <a:prstGeom prst="rect">
-            <a:avLst/>
-          </a:prstGeom>
-          <a:solidFill>
-            <a:srgbClr val="1E7A52"/>
-          </a:solidFill>
-          <a:ln/>
-        </p:spPr>
-      </p:sp>
-      <p:sp>
-        <p:nvSpPr>
-          <p:cNvPr id="41" name="Shape 39"/>
-          <p:cNvSpPr/>
-          <p:nvPr/>
-        </p:nvSpPr>
-        <p:spPr>
-          <a:xfrm>
-            <a:off x="713232" y="4562856"/>
-            <a:ext cx="274320" cy="274320"/>
-          </a:xfrm>
-          <a:prstGeom prst="ellipse">
-            <a:avLst/>
-          </a:prstGeom>
-          <a:solidFill>
-            <a:srgbClr val="1E7A52"/>
-          </a:solidFill>
-          <a:ln/>
-        </p:spPr>
-      </p:sp>
-      <p:sp>
-        <p:nvSpPr>
-          <p:cNvPr id="42" name="Text 40"/>
+          <p:cNvPr id="39" name="Text 37"/>
           <p:cNvSpPr txBox="1"/>
           <p:nvPr/>
         </p:nvSpPr>
         <p:spPr>
           <a:xfrm>
-            <a:off x="713232" y="4562856"/>
-            <a:ext cx="274320" cy="274320"/>
+            <a:off x="3694176" y="5440680"/>
+            <a:ext cx="7747711" cy="896112"/>
           </a:xfrm>
           <a:prstGeom prst="rect">
             <a:avLst/>
@@ -10907,89 +10890,11 @@
           <a:bodyPr wrap="square" lIns="0" tIns="0" rIns="0" bIns="0" rtlCol="0" anchor="ctr"/>
           <a:lstStyle/>
           <a:p>
-            <a:pPr algn="ctr" indent="0" marL="0">
-              <a:buNone/>
-            </a:pPr>
-            <a:r>
-              <a:rPr lang="en-US" sz="1450" b="1" dirty="0">
-                <a:solidFill>
-                  <a:srgbClr val="F5F6F8"/>
-                </a:solidFill>
-                <a:latin typeface="Georgia" pitchFamily="34" charset="0"/>
-                <a:ea typeface="Georgia" pitchFamily="34" charset="-122"/>
-                <a:cs typeface="Georgia" pitchFamily="34" charset="-120"/>
-              </a:rPr>
-              <a:t>5</a:t>
-            </a:r>
-            <a:endParaRPr lang="en-US" sz="1450" dirty="0"/>
-          </a:p>
-        </p:txBody>
-      </p:sp>
-      <p:sp>
-        <p:nvSpPr>
-          <p:cNvPr id="43" name="Text 41"/>
-          <p:cNvSpPr txBox="1"/>
-          <p:nvPr/>
-        </p:nvSpPr>
-        <p:spPr>
-          <a:xfrm>
-            <a:off x="1078992" y="4544568"/>
-            <a:ext cx="2596896" cy="329184"/>
-          </a:xfrm>
-          <a:prstGeom prst="rect">
-            <a:avLst/>
-          </a:prstGeom>
-          <a:noFill/>
-          <a:ln/>
-        </p:spPr>
-        <p:txBody>
-          <a:bodyPr wrap="square" lIns="0" tIns="0" rIns="0" bIns="0" rtlCol="0" anchor="ctr"/>
-          <a:lstStyle/>
-          <a:p>
             <a:pPr indent="0" marL="0">
               <a:buNone/>
             </a:pPr>
             <a:r>
-              <a:rPr lang="en-US" sz="1400" b="1" dirty="0">
-                <a:solidFill>
-                  <a:srgbClr val="1B202A"/>
-                </a:solidFill>
-                <a:latin typeface="Georgia" pitchFamily="34" charset="0"/>
-                <a:ea typeface="Georgia" pitchFamily="34" charset="-122"/>
-                <a:cs typeface="Georgia" pitchFamily="34" charset="-120"/>
-              </a:rPr>
-              <a:t>Significant consequences</a:t>
-            </a:r>
-            <a:endParaRPr lang="en-US" sz="1400" dirty="0"/>
-          </a:p>
-        </p:txBody>
-      </p:sp>
-      <p:sp>
-        <p:nvSpPr>
-          <p:cNvPr id="44" name="Text 42"/>
-          <p:cNvSpPr txBox="1"/>
-          <p:nvPr/>
-        </p:nvSpPr>
-        <p:spPr>
-          <a:xfrm>
-            <a:off x="713232" y="4882896"/>
-            <a:ext cx="2944368" cy="676656"/>
-          </a:xfrm>
-          <a:prstGeom prst="rect">
-            <a:avLst/>
-          </a:prstGeom>
-          <a:noFill/>
-          <a:ln/>
-        </p:spPr>
-        <p:txBody>
-          <a:bodyPr wrap="square" lIns="0" tIns="0" rIns="0" bIns="0" rtlCol="0" anchor="ctr"/>
-          <a:lstStyle/>
-          <a:p>
-            <a:pPr indent="0" marL="0">
-              <a:buNone/>
-            </a:pPr>
-            <a:r>
-              <a:rPr lang="en-US" sz="1150" dirty="0">
+              <a:rPr lang="en-US" sz="1450" dirty="0">
                 <a:solidFill>
                   <a:srgbClr val="596273"/>
                 </a:solidFill>
@@ -10997,281 +10902,12 @@
                 <a:ea typeface="Calibri" pitchFamily="34" charset="-122"/>
                 <a:cs typeface="Calibri" pitchFamily="34" charset="-120"/>
               </a:rPr>
-              <a:t>A missed failure ships a wrong answer, undetected</a:t>
-            </a:r>
-            <a:endParaRPr lang="en-US" sz="1150" dirty="0"/>
+              <a:t>3 unknowns: whether, which step, what's correct</a:t>
+            </a:r>
+            <a:endParaRPr lang="en-US" sz="1450" dirty="0"/>
           </a:p>
         </p:txBody>
       </p:sp>
-      <p:sp>
-        <p:nvSpPr>
-          <p:cNvPr id="45" name="Shape 43"/>
-          <p:cNvSpPr/>
-          <p:nvPr/>
-        </p:nvSpPr>
-        <p:spPr>
-          <a:xfrm>
-            <a:off x="3970325" y="4469587"/>
-            <a:ext cx="3218688" cy="1170432"/>
-          </a:xfrm>
-          <a:prstGeom prst="roundRect">
-            <a:avLst>
-              <a:gd name="adj" fmla="val 4688"/>
-            </a:avLst>
-          </a:prstGeom>
-          <a:solidFill>
-            <a:srgbClr val="E4E6EB"/>
-          </a:solidFill>
-          <a:ln/>
-        </p:spPr>
-      </p:sp>
-      <p:sp>
-        <p:nvSpPr>
-          <p:cNvPr id="46" name="Shape 44"/>
-          <p:cNvSpPr/>
-          <p:nvPr/>
-        </p:nvSpPr>
-        <p:spPr>
-          <a:xfrm>
-            <a:off x="3950208" y="4443984"/>
-            <a:ext cx="3218688" cy="1170432"/>
-          </a:xfrm>
-          <a:prstGeom prst="roundRect">
-            <a:avLst>
-              <a:gd name="adj" fmla="val 4688"/>
-            </a:avLst>
-          </a:prstGeom>
-          <a:solidFill>
-            <a:srgbClr val="E6F1EB"/>
-          </a:solidFill>
-          <a:ln w="9525">
-            <a:solidFill>
-              <a:srgbClr val="D9DCE3"/>
-            </a:solidFill>
-            <a:prstDash val="solid"/>
-          </a:ln>
-        </p:spPr>
-      </p:sp>
-      <p:sp>
-        <p:nvSpPr>
-          <p:cNvPr id="47" name="Shape 45"/>
-          <p:cNvSpPr/>
-          <p:nvPr/>
-        </p:nvSpPr>
-        <p:spPr>
-          <a:xfrm>
-            <a:off x="3950208" y="4498848"/>
-            <a:ext cx="41148" cy="1060704"/>
-          </a:xfrm>
-          <a:prstGeom prst="rect">
-            <a:avLst/>
-          </a:prstGeom>
-          <a:solidFill>
-            <a:srgbClr val="1E7A52"/>
-          </a:solidFill>
-          <a:ln/>
-        </p:spPr>
-      </p:sp>
-      <p:sp>
-        <p:nvSpPr>
-          <p:cNvPr id="48" name="Shape 46"/>
-          <p:cNvSpPr/>
-          <p:nvPr/>
-        </p:nvSpPr>
-        <p:spPr>
-          <a:xfrm>
-            <a:off x="4096512" y="4562856"/>
-            <a:ext cx="274320" cy="274320"/>
-          </a:xfrm>
-          <a:prstGeom prst="ellipse">
-            <a:avLst/>
-          </a:prstGeom>
-          <a:solidFill>
-            <a:srgbClr val="1E7A52"/>
-          </a:solidFill>
-          <a:ln/>
-        </p:spPr>
-      </p:sp>
-      <p:sp>
-        <p:nvSpPr>
-          <p:cNvPr id="49" name="Text 47"/>
-          <p:cNvSpPr txBox="1"/>
-          <p:nvPr/>
-        </p:nvSpPr>
-        <p:spPr>
-          <a:xfrm>
-            <a:off x="4096512" y="4562856"/>
-            <a:ext cx="274320" cy="274320"/>
-          </a:xfrm>
-          <a:prstGeom prst="rect">
-            <a:avLst/>
-          </a:prstGeom>
-          <a:noFill/>
-          <a:ln/>
-        </p:spPr>
-        <p:txBody>
-          <a:bodyPr wrap="square" lIns="0" tIns="0" rIns="0" bIns="0" rtlCol="0" anchor="ctr"/>
-          <a:lstStyle/>
-          <a:p>
-            <a:pPr algn="ctr" indent="0" marL="0">
-              <a:buNone/>
-            </a:pPr>
-            <a:r>
-              <a:rPr lang="en-US" sz="1450" b="1" dirty="0">
-                <a:solidFill>
-                  <a:srgbClr val="F5F6F8"/>
-                </a:solidFill>
-                <a:latin typeface="Georgia" pitchFamily="34" charset="0"/>
-                <a:ea typeface="Georgia" pitchFamily="34" charset="-122"/>
-                <a:cs typeface="Georgia" pitchFamily="34" charset="-120"/>
-              </a:rPr>
-              <a:t>6</a:t>
-            </a:r>
-            <a:endParaRPr lang="en-US" sz="1450" dirty="0"/>
-          </a:p>
-        </p:txBody>
-      </p:sp>
-      <p:sp>
-        <p:nvSpPr>
-          <p:cNvPr id="50" name="Text 48"/>
-          <p:cNvSpPr txBox="1"/>
-          <p:nvPr/>
-        </p:nvSpPr>
-        <p:spPr>
-          <a:xfrm>
-            <a:off x="4462272" y="4544568"/>
-            <a:ext cx="2596896" cy="329184"/>
-          </a:xfrm>
-          <a:prstGeom prst="rect">
-            <a:avLst/>
-          </a:prstGeom>
-          <a:noFill/>
-          <a:ln/>
-        </p:spPr>
-        <p:txBody>
-          <a:bodyPr wrap="square" lIns="0" tIns="0" rIns="0" bIns="0" rtlCol="0" anchor="ctr"/>
-          <a:lstStyle/>
-          <a:p>
-            <a:pPr indent="0" marL="0">
-              <a:buNone/>
-            </a:pPr>
-            <a:r>
-              <a:rPr lang="en-US" sz="1400" b="1" dirty="0">
-                <a:solidFill>
-                  <a:srgbClr val="1B202A"/>
-                </a:solidFill>
-                <a:latin typeface="Georgia" pitchFamily="34" charset="0"/>
-                <a:ea typeface="Georgia" pitchFamily="34" charset="-122"/>
-                <a:cs typeface="Georgia" pitchFamily="34" charset="-120"/>
-              </a:rPr>
-              <a:t>Ill-defined cause</a:t>
-            </a:r>
-            <a:endParaRPr lang="en-US" sz="1400" dirty="0"/>
-          </a:p>
-        </p:txBody>
-      </p:sp>
-      <p:sp>
-        <p:nvSpPr>
-          <p:cNvPr id="51" name="Text 49"/>
-          <p:cNvSpPr txBox="1"/>
-          <p:nvPr/>
-        </p:nvSpPr>
-        <p:spPr>
-          <a:xfrm>
-            <a:off x="4096512" y="4882896"/>
-            <a:ext cx="2944368" cy="676656"/>
-          </a:xfrm>
-          <a:prstGeom prst="rect">
-            <a:avLst/>
-          </a:prstGeom>
-          <a:noFill/>
-          <a:ln/>
-        </p:spPr>
-        <p:txBody>
-          <a:bodyPr wrap="square" lIns="0" tIns="0" rIns="0" bIns="0" rtlCol="0" anchor="ctr"/>
-          <a:lstStyle/>
-          <a:p>
-            <a:pPr indent="0" marL="0">
-              <a:buNone/>
-            </a:pPr>
-            <a:r>
-              <a:rPr lang="en-US" sz="1150" dirty="0">
-                <a:solidFill>
-                  <a:srgbClr val="596273"/>
-                </a:solidFill>
-                <a:latin typeface="Calibri" pitchFamily="34" charset="0"/>
-                <a:ea typeface="Calibri" pitchFamily="34" charset="-122"/>
-                <a:cs typeface="Calibri" pitchFamily="34" charset="-120"/>
-              </a:rPr>
-              <a:t>3 unknowns: whether, which step, what's correct</a:t>
-            </a:r>
-            <a:endParaRPr lang="en-US" sz="1150" dirty="0"/>
-          </a:p>
-        </p:txBody>
-      </p:sp>
-      <p:sp>
-        <p:nvSpPr>
-          <p:cNvPr id="52" name="Text 50"/>
-          <p:cNvSpPr txBox="1"/>
-          <p:nvPr/>
-        </p:nvSpPr>
-        <p:spPr>
-          <a:xfrm>
-            <a:off x="7644384" y="1298448"/>
-            <a:ext cx="3980383" cy="182880"/>
-          </a:xfrm>
-          <a:prstGeom prst="rect">
-            <a:avLst/>
-          </a:prstGeom>
-          <a:noFill/>
-          <a:ln/>
-        </p:spPr>
-        <p:txBody>
-          <a:bodyPr wrap="square" lIns="0" tIns="0" rIns="0" bIns="0" rtlCol="0" anchor="ctr"/>
-          <a:lstStyle/>
-          <a:p>
-            <a:pPr indent="0" marL="0">
-              <a:buNone/>
-            </a:pPr>
-            <a:r>
-              <a:rPr lang="en-US" sz="1050" b="1" spc="60" kern="0" dirty="0">
-                <a:solidFill>
-                  <a:srgbClr val="8E6A1F"/>
-                </a:solidFill>
-                <a:latin typeface="Consolas" pitchFamily="34" charset="0"/>
-                <a:ea typeface="Consolas" pitchFamily="34" charset="-122"/>
-                <a:cs typeface="Consolas" pitchFamily="34" charset="-120"/>
-              </a:rPr>
-              <a:t>CORE PIPELINE — HYPOTHESIS TO VERIFIED REPAIR</a:t>
-            </a:r>
-            <a:endParaRPr lang="en-US" sz="1050" dirty="0"/>
-          </a:p>
-        </p:txBody>
-      </p:sp>
-      <p:pic>
-        <p:nvPicPr>
-          <p:cNvPr id="53" name="Image 0" descr="diagram4_cropped.png">    </p:cNvPr>
-          <p:cNvPicPr>
-            <a:picLocks noChangeAspect="1"/>
-          </p:cNvPicPr>
-          <p:nvPr/>
-        </p:nvPicPr>
-        <p:blipFill>
-          <a:blip r:embed="rId1"/>
-          <a:stretch>
-            <a:fillRect/>
-          </a:stretch>
-        </p:blipFill>
-        <p:spPr>
-          <a:xfrm>
-            <a:off x="7644384" y="1517904"/>
-            <a:ext cx="3921337" cy="4846320"/>
-          </a:xfrm>
-          <a:prstGeom prst="rect">
-            <a:avLst/>
-          </a:prstGeom>
-        </p:spPr>
-      </p:pic>
     </p:spTree>
   </p:cSld>
   <p:clrMapOvr>
@@ -16565,7 +16201,7 @@
         <p:spPr>
           <a:xfrm>
             <a:off x="566928" y="4700016"/>
-            <a:ext cx="4754880" cy="182880"/>
+            <a:ext cx="11057839" cy="182880"/>
           </a:xfrm>
           <a:prstGeom prst="rect">
             <a:avLst/>
@@ -16612,70 +16248,7 @@
         <p:spPr>
           <a:xfrm>
             <a:off x="566928" y="4919472"/>
-            <a:ext cx="4754880" cy="1290610"/>
-          </a:xfrm>
-          <a:prstGeom prst="rect">
-            <a:avLst/>
-          </a:prstGeom>
-        </p:spPr>
-      </p:pic>
-      <p:sp>
-        <p:nvSpPr>
-          <p:cNvPr id="18" name="Text 14"/>
-          <p:cNvSpPr txBox="1"/>
-          <p:nvPr/>
-        </p:nvSpPr>
-        <p:spPr>
-          <a:xfrm>
-            <a:off x="5733288" y="4700016"/>
-            <a:ext cx="3520440" cy="182880"/>
-          </a:xfrm>
-          <a:prstGeom prst="rect">
-            <a:avLst/>
-          </a:prstGeom>
-          <a:noFill/>
-          <a:ln/>
-        </p:spPr>
-        <p:txBody>
-          <a:bodyPr wrap="square" lIns="0" tIns="0" rIns="0" bIns="0" rtlCol="0" anchor="ctr"/>
-          <a:lstStyle/>
-          <a:p>
-            <a:pPr indent="0" marL="0">
-              <a:buNone/>
-            </a:pPr>
-            <a:r>
-              <a:rPr lang="en-US" sz="1050" b="1" spc="40" kern="0" dirty="0">
-                <a:solidFill>
-                  <a:srgbClr val="8E6A1F"/>
-                </a:solidFill>
-                <a:latin typeface="Consolas" pitchFamily="34" charset="0"/>
-                <a:ea typeface="Consolas" pitchFamily="34" charset="-122"/>
-                <a:cs typeface="Consolas" pitchFamily="34" charset="-120"/>
-              </a:rPr>
-              <a:t>OPERATOR WORKFLOW</a:t>
-            </a:r>
-            <a:endParaRPr lang="en-US" sz="1050" dirty="0"/>
-          </a:p>
-        </p:txBody>
-      </p:sp>
-      <p:pic>
-        <p:nvPicPr>
-          <p:cNvPr id="19" name="Image 1" descr="diagram7_cropped.png">    </p:cNvPr>
-          <p:cNvPicPr>
-            <a:picLocks noChangeAspect="1"/>
-          </p:cNvPicPr>
-          <p:nvPr/>
-        </p:nvPicPr>
-        <p:blipFill>
-          <a:blip r:embed="rId2"/>
-          <a:stretch>
-            <a:fillRect/>
-          </a:stretch>
-        </p:blipFill>
-        <p:spPr>
-          <a:xfrm>
-            <a:off x="5733288" y="4901184"/>
-            <a:ext cx="3520440" cy="1437513"/>
+            <a:ext cx="11057839" cy="1554480"/>
           </a:xfrm>
           <a:prstGeom prst="rect">
             <a:avLst/>
@@ -17160,49 +16733,7 @@
                 <a:ea typeface="Calibri" pitchFamily="34" charset="-122"/>
                 <a:cs typeface="Calibri" pitchFamily="34" charset="-120"/>
               </a:rPr>
-              <a:t>SF precision/recall + abstention rate</a:t>
-            </a:r>
-            <a:endParaRPr lang="en-US" sz="1470" dirty="0"/>
-          </a:p>
-          <a:p>
-            <a:pPr marL="190500" indent="-190500">
-              <a:spcAft>
-                <a:spcPts val="900"/>
-              </a:spcAft>
-              <a:buSzPct val="100000"/>
-              <a:buChar char="▪"/>
-            </a:pPr>
-            <a:r>
-              <a:rPr lang="en-US" sz="1470" dirty="0">
-                <a:solidFill>
-                  <a:srgbClr val="1B202A"/>
-                </a:solidFill>
-                <a:latin typeface="Calibri" pitchFamily="34" charset="0"/>
-                <a:ea typeface="Calibri" pitchFamily="34" charset="-122"/>
-                <a:cs typeface="Calibri" pitchFamily="34" charset="-120"/>
-              </a:rPr>
-              <a:t>False-positive rate on clean controls</a:t>
-            </a:r>
-            <a:endParaRPr lang="en-US" sz="1470" dirty="0"/>
-          </a:p>
-          <a:p>
-            <a:pPr marL="190500" indent="-190500">
-              <a:spcAft>
-                <a:spcPts val="900"/>
-              </a:spcAft>
-              <a:buSzPct val="100000"/>
-              <a:buChar char="▪"/>
-            </a:pPr>
-            <a:r>
-              <a:rPr lang="en-US" sz="1470" dirty="0">
-                <a:solidFill>
-                  <a:srgbClr val="1B202A"/>
-                </a:solidFill>
-                <a:latin typeface="Calibri" pitchFamily="34" charset="0"/>
-                <a:ea typeface="Calibri" pitchFamily="34" charset="-122"/>
-                <a:cs typeface="Calibri" pitchFamily="34" charset="-120"/>
-              </a:rPr>
-              <a:t>Completion, recovery, repair success rates</a:t>
+              <a:t>SF precision/recall + FPR on clean controls</a:t>
             </a:r>
             <a:endParaRPr lang="en-US" sz="1470" dirty="0"/>
           </a:p>
@@ -17446,11 +16977,11 @@
         <p:spPr>
           <a:xfrm>
             <a:off x="5716829" y="2403043"/>
-            <a:ext cx="2606040" cy="786384"/>
+            <a:ext cx="2606040" cy="1051560"/>
           </a:xfrm>
           <a:prstGeom prst="roundRect">
             <a:avLst>
-              <a:gd name="adj" fmla="val 6977"/>
+              <a:gd name="adj" fmla="val 5217"/>
             </a:avLst>
           </a:prstGeom>
           <a:solidFill>
@@ -17468,158 +16999,11 @@
         <p:spPr>
           <a:xfrm>
             <a:off x="5696712" y="2377440"/>
-            <a:ext cx="2606040" cy="786384"/>
+            <a:ext cx="2606040" cy="1051560"/>
           </a:xfrm>
           <a:prstGeom prst="roundRect">
             <a:avLst>
-              <a:gd name="adj" fmla="val 6977"/>
-            </a:avLst>
-          </a:prstGeom>
-          <a:solidFill>
-            <a:srgbClr val="F6E6E3"/>
-          </a:solidFill>
-          <a:ln w="9525">
-            <a:solidFill>
-              <a:srgbClr val="D9DCE3"/>
-            </a:solidFill>
-            <a:prstDash val="solid"/>
-          </a:ln>
-        </p:spPr>
-      </p:sp>
-      <p:sp>
-        <p:nvSpPr>
-          <p:cNvPr id="23" name="Shape 21"/>
-          <p:cNvSpPr/>
-          <p:nvPr/>
-        </p:nvSpPr>
-        <p:spPr>
-          <a:xfrm>
-            <a:off x="5696712" y="2432304"/>
-            <a:ext cx="41148" cy="676656"/>
-          </a:xfrm>
-          <a:prstGeom prst="rect">
-            <a:avLst/>
-          </a:prstGeom>
-          <a:solidFill>
-            <a:srgbClr val="A83A30"/>
-          </a:solidFill>
-          <a:ln/>
-        </p:spPr>
-      </p:sp>
-      <p:sp>
-        <p:nvSpPr>
-          <p:cNvPr id="24" name="Text 22"/>
-          <p:cNvSpPr txBox="1"/>
-          <p:nvPr/>
-        </p:nvSpPr>
-        <p:spPr>
-          <a:xfrm>
-            <a:off x="5861304" y="2432304"/>
-            <a:ext cx="2276856" cy="256032"/>
-          </a:xfrm>
-          <a:prstGeom prst="rect">
-            <a:avLst/>
-          </a:prstGeom>
-          <a:noFill/>
-          <a:ln/>
-        </p:spPr>
-        <p:txBody>
-          <a:bodyPr wrap="square" lIns="0" tIns="0" rIns="0" bIns="0" rtlCol="0" anchor="ctr"/>
-          <a:lstStyle/>
-          <a:p>
-            <a:pPr indent="0" marL="0">
-              <a:buNone/>
-            </a:pPr>
-            <a:r>
-              <a:rPr lang="en-US" sz="1450" b="1" dirty="0">
-                <a:solidFill>
-                  <a:srgbClr val="A83A30"/>
-                </a:solidFill>
-                <a:latin typeface="Georgia" pitchFamily="34" charset="0"/>
-                <a:ea typeface="Georgia" pitchFamily="34" charset="-122"/>
-                <a:cs typeface="Georgia" pitchFamily="34" charset="-120"/>
-              </a:rPr>
-              <a:t>Failure</a:t>
-            </a:r>
-            <a:endParaRPr lang="en-US" sz="1450" dirty="0"/>
-          </a:p>
-        </p:txBody>
-      </p:sp>
-      <p:sp>
-        <p:nvSpPr>
-          <p:cNvPr id="25" name="Text 23"/>
-          <p:cNvSpPr txBox="1"/>
-          <p:nvPr/>
-        </p:nvSpPr>
-        <p:spPr>
-          <a:xfrm>
-            <a:off x="5861304" y="2724912"/>
-            <a:ext cx="2276856" cy="402336"/>
-          </a:xfrm>
-          <a:prstGeom prst="rect">
-            <a:avLst/>
-          </a:prstGeom>
-          <a:noFill/>
-          <a:ln/>
-        </p:spPr>
-        <p:txBody>
-          <a:bodyPr wrap="square" lIns="0" tIns="0" rIns="0" bIns="0" rtlCol="0" anchor="ctr"/>
-          <a:lstStyle/>
-          <a:p>
-            <a:pPr indent="0" marL="0">
-              <a:buNone/>
-            </a:pPr>
-            <a:r>
-              <a:rPr lang="en-US" sz="1130" dirty="0">
-                <a:solidFill>
-                  <a:srgbClr val="1B202A"/>
-                </a:solidFill>
-                <a:latin typeface="Calibri" pitchFamily="34" charset="0"/>
-                <a:ea typeface="Calibri" pitchFamily="34" charset="-122"/>
-                <a:cs typeface="Calibri" pitchFamily="34" charset="-120"/>
-              </a:rPr>
-              <a:t>No measurable improvement anywhere</a:t>
-            </a:r>
-            <a:endParaRPr lang="en-US" sz="1130" dirty="0"/>
-          </a:p>
-        </p:txBody>
-      </p:sp>
-      <p:sp>
-        <p:nvSpPr>
-          <p:cNvPr id="26" name="Shape 24"/>
-          <p:cNvSpPr/>
-          <p:nvPr/>
-        </p:nvSpPr>
-        <p:spPr>
-          <a:xfrm>
-            <a:off x="5716829" y="3244291"/>
-            <a:ext cx="2606040" cy="786384"/>
-          </a:xfrm>
-          <a:prstGeom prst="roundRect">
-            <a:avLst>
-              <a:gd name="adj" fmla="val 6977"/>
-            </a:avLst>
-          </a:prstGeom>
-          <a:solidFill>
-            <a:srgbClr val="E4E6EB"/>
-          </a:solidFill>
-          <a:ln/>
-        </p:spPr>
-      </p:sp>
-      <p:sp>
-        <p:nvSpPr>
-          <p:cNvPr id="27" name="Shape 25"/>
-          <p:cNvSpPr/>
-          <p:nvPr/>
-        </p:nvSpPr>
-        <p:spPr>
-          <a:xfrm>
-            <a:off x="5696712" y="3218688"/>
-            <a:ext cx="2606040" cy="786384"/>
-          </a:xfrm>
-          <a:prstGeom prst="roundRect">
-            <a:avLst>
-              <a:gd name="adj" fmla="val 6977"/>
+              <a:gd name="adj" fmla="val 5217"/>
             </a:avLst>
           </a:prstGeom>
           <a:solidFill>
@@ -17635,14 +17019,14 @@
       </p:sp>
       <p:sp>
         <p:nvSpPr>
-          <p:cNvPr id="28" name="Shape 26"/>
+          <p:cNvPr id="23" name="Shape 21"/>
           <p:cNvSpPr/>
           <p:nvPr/>
         </p:nvSpPr>
         <p:spPr>
           <a:xfrm>
-            <a:off x="5696712" y="3273552"/>
-            <a:ext cx="41148" cy="676656"/>
+            <a:off x="5696712" y="2432304"/>
+            <a:ext cx="41148" cy="941832"/>
           </a:xfrm>
           <a:prstGeom prst="rect">
             <a:avLst/>
@@ -17655,14 +17039,14 @@
       </p:sp>
       <p:sp>
         <p:nvSpPr>
-          <p:cNvPr id="29" name="Text 27"/>
+          <p:cNvPr id="24" name="Text 22"/>
           <p:cNvSpPr txBox="1"/>
           <p:nvPr/>
         </p:nvSpPr>
         <p:spPr>
           <a:xfrm>
-            <a:off x="5861304" y="3273552"/>
-            <a:ext cx="2276856" cy="256032"/>
+            <a:off x="5861304" y="2468880"/>
+            <a:ext cx="2276856" cy="274320"/>
           </a:xfrm>
           <a:prstGeom prst="rect">
             <a:avLst/>
@@ -17694,14 +17078,14 @@
       </p:sp>
       <p:sp>
         <p:nvSpPr>
-          <p:cNvPr id="30" name="Text 28"/>
+          <p:cNvPr id="25" name="Text 23"/>
           <p:cNvSpPr txBox="1"/>
           <p:nvPr/>
         </p:nvSpPr>
         <p:spPr>
           <a:xfrm>
-            <a:off x="5861304" y="3566160"/>
-            <a:ext cx="2276856" cy="402336"/>
+            <a:off x="5861304" y="2798064"/>
+            <a:ext cx="2276856" cy="566928"/>
           </a:xfrm>
           <a:prstGeom prst="rect">
             <a:avLst/>
@@ -17717,7 +17101,7 @@
               <a:buNone/>
             </a:pPr>
             <a:r>
-              <a:rPr lang="en-US" sz="1130" dirty="0">
+              <a:rPr lang="en-US" sz="1150" dirty="0">
                 <a:solidFill>
                   <a:srgbClr val="1B202A"/>
                 </a:solidFill>
@@ -17727,24 +17111,24 @@
               </a:rPr>
               <a:t>Parity on Who&amp;When + any cross-arch</a:t>
             </a:r>
-            <a:endParaRPr lang="en-US" sz="1130" dirty="0"/>
+            <a:endParaRPr lang="en-US" sz="1150" dirty="0"/>
           </a:p>
         </p:txBody>
       </p:sp>
       <p:sp>
         <p:nvSpPr>
-          <p:cNvPr id="31" name="Shape 29"/>
+          <p:cNvPr id="26" name="Shape 24"/>
           <p:cNvSpPr/>
           <p:nvPr/>
         </p:nvSpPr>
         <p:spPr>
           <a:xfrm>
-            <a:off x="5716829" y="4085539"/>
-            <a:ext cx="2606040" cy="786384"/>
+            <a:off x="5716829" y="3509467"/>
+            <a:ext cx="2606040" cy="1051560"/>
           </a:xfrm>
           <a:prstGeom prst="roundRect">
             <a:avLst>
-              <a:gd name="adj" fmla="val 6977"/>
+              <a:gd name="adj" fmla="val 5217"/>
             </a:avLst>
           </a:prstGeom>
           <a:solidFill>
@@ -17755,18 +17139,18 @@
       </p:sp>
       <p:sp>
         <p:nvSpPr>
-          <p:cNvPr id="32" name="Shape 30"/>
+          <p:cNvPr id="27" name="Shape 25"/>
           <p:cNvSpPr/>
           <p:nvPr/>
         </p:nvSpPr>
         <p:spPr>
           <a:xfrm>
-            <a:off x="5696712" y="4059936"/>
-            <a:ext cx="2606040" cy="786384"/>
+            <a:off x="5696712" y="3483864"/>
+            <a:ext cx="2606040" cy="1051560"/>
           </a:xfrm>
           <a:prstGeom prst="roundRect">
             <a:avLst>
-              <a:gd name="adj" fmla="val 6977"/>
+              <a:gd name="adj" fmla="val 5217"/>
             </a:avLst>
           </a:prstGeom>
           <a:solidFill>
@@ -17782,14 +17166,14 @@
       </p:sp>
       <p:sp>
         <p:nvSpPr>
-          <p:cNvPr id="33" name="Shape 31"/>
+          <p:cNvPr id="28" name="Shape 26"/>
           <p:cNvSpPr/>
           <p:nvPr/>
         </p:nvSpPr>
         <p:spPr>
           <a:xfrm>
-            <a:off x="5696712" y="4114800"/>
-            <a:ext cx="41148" cy="676656"/>
+            <a:off x="5696712" y="3538728"/>
+            <a:ext cx="41148" cy="941832"/>
           </a:xfrm>
           <a:prstGeom prst="rect">
             <a:avLst/>
@@ -17802,14 +17186,14 @@
       </p:sp>
       <p:sp>
         <p:nvSpPr>
-          <p:cNvPr id="34" name="Text 32"/>
+          <p:cNvPr id="29" name="Text 27"/>
           <p:cNvSpPr txBox="1"/>
           <p:nvPr/>
         </p:nvSpPr>
         <p:spPr>
           <a:xfrm>
-            <a:off x="5861304" y="4114800"/>
-            <a:ext cx="2276856" cy="256032"/>
+            <a:off x="5861304" y="3575304"/>
+            <a:ext cx="2276856" cy="274320"/>
           </a:xfrm>
           <a:prstGeom prst="rect">
             <a:avLst/>
@@ -17841,14 +17225,14 @@
       </p:sp>
       <p:sp>
         <p:nvSpPr>
-          <p:cNvPr id="35" name="Text 33"/>
+          <p:cNvPr id="30" name="Text 28"/>
           <p:cNvSpPr txBox="1"/>
           <p:nvPr/>
         </p:nvSpPr>
         <p:spPr>
           <a:xfrm>
-            <a:off x="5861304" y="4407408"/>
-            <a:ext cx="2276856" cy="402336"/>
+            <a:off x="5861304" y="3904488"/>
+            <a:ext cx="2276856" cy="566928"/>
           </a:xfrm>
           <a:prstGeom prst="rect">
             <a:avLst/>
@@ -17864,7 +17248,7 @@
               <a:buNone/>
             </a:pPr>
             <a:r>
-              <a:rPr lang="en-US" sz="1130" dirty="0">
+              <a:rPr lang="en-US" sz="1150" dirty="0">
                 <a:solidFill>
                   <a:srgbClr val="1B202A"/>
                 </a:solidFill>
@@ -17874,24 +17258,24 @@
               </a:rPr>
               <a:t>Beats baseline, unseen archs, &gt;70% SF</a:t>
             </a:r>
-            <a:endParaRPr lang="en-US" sz="1130" dirty="0"/>
+            <a:endParaRPr lang="en-US" sz="1150" dirty="0"/>
           </a:p>
         </p:txBody>
       </p:sp>
       <p:sp>
         <p:nvSpPr>
-          <p:cNvPr id="36" name="Shape 34"/>
+          <p:cNvPr id="31" name="Shape 29"/>
           <p:cNvSpPr/>
           <p:nvPr/>
         </p:nvSpPr>
         <p:spPr>
           <a:xfrm>
-            <a:off x="5716829" y="4926787"/>
-            <a:ext cx="2606040" cy="786384"/>
+            <a:off x="5716829" y="4615891"/>
+            <a:ext cx="2606040" cy="1051560"/>
           </a:xfrm>
           <a:prstGeom prst="roundRect">
             <a:avLst>
-              <a:gd name="adj" fmla="val 6977"/>
+              <a:gd name="adj" fmla="val 5217"/>
             </a:avLst>
           </a:prstGeom>
           <a:solidFill>
@@ -17902,18 +17286,18 @@
       </p:sp>
       <p:sp>
         <p:nvSpPr>
-          <p:cNvPr id="37" name="Shape 35"/>
+          <p:cNvPr id="32" name="Shape 30"/>
           <p:cNvSpPr/>
           <p:nvPr/>
         </p:nvSpPr>
         <p:spPr>
           <a:xfrm>
-            <a:off x="5696712" y="4901184"/>
-            <a:ext cx="2606040" cy="786384"/>
+            <a:off x="5696712" y="4590288"/>
+            <a:ext cx="2606040" cy="1051560"/>
           </a:xfrm>
           <a:prstGeom prst="roundRect">
             <a:avLst>
-              <a:gd name="adj" fmla="val 6977"/>
+              <a:gd name="adj" fmla="val 5217"/>
             </a:avLst>
           </a:prstGeom>
           <a:solidFill>
@@ -17929,14 +17313,14 @@
       </p:sp>
       <p:sp>
         <p:nvSpPr>
-          <p:cNvPr id="38" name="Shape 36"/>
+          <p:cNvPr id="33" name="Shape 31"/>
           <p:cNvSpPr/>
           <p:nvPr/>
         </p:nvSpPr>
         <p:spPr>
           <a:xfrm>
-            <a:off x="5696712" y="4956048"/>
-            <a:ext cx="41148" cy="676656"/>
+            <a:off x="5696712" y="4645152"/>
+            <a:ext cx="41148" cy="941832"/>
           </a:xfrm>
           <a:prstGeom prst="rect">
             <a:avLst/>
@@ -17949,14 +17333,14 @@
       </p:sp>
       <p:sp>
         <p:nvSpPr>
-          <p:cNvPr id="39" name="Text 37"/>
+          <p:cNvPr id="34" name="Text 32"/>
           <p:cNvSpPr txBox="1"/>
           <p:nvPr/>
         </p:nvSpPr>
         <p:spPr>
           <a:xfrm>
-            <a:off x="5861304" y="4956048"/>
-            <a:ext cx="2276856" cy="256032"/>
+            <a:off x="5861304" y="4681728"/>
+            <a:ext cx="2276856" cy="274320"/>
           </a:xfrm>
           <a:prstGeom prst="rect">
             <a:avLst/>
@@ -17988,14 +17372,14 @@
       </p:sp>
       <p:sp>
         <p:nvSpPr>
-          <p:cNvPr id="40" name="Text 38"/>
+          <p:cNvPr id="35" name="Text 33"/>
           <p:cNvSpPr txBox="1"/>
           <p:nvPr/>
         </p:nvSpPr>
         <p:spPr>
           <a:xfrm>
-            <a:off x="5861304" y="5248656"/>
-            <a:ext cx="2276856" cy="402336"/>
+            <a:off x="5861304" y="5010912"/>
+            <a:ext cx="2276856" cy="566928"/>
           </a:xfrm>
           <a:prstGeom prst="rect">
             <a:avLst/>
@@ -18011,7 +17395,7 @@
               <a:buNone/>
             </a:pPr>
             <a:r>
-              <a:rPr lang="en-US" sz="1130" dirty="0">
+              <a:rPr lang="en-US" sz="1150" dirty="0">
                 <a:solidFill>
                   <a:srgbClr val="1B202A"/>
                 </a:solidFill>
@@ -18021,13 +17405,13 @@
               </a:rPr>
               <a:t>Strong + &gt;50% verified-repair recovery</a:t>
             </a:r>
-            <a:endParaRPr lang="en-US" sz="1130" dirty="0"/>
+            <a:endParaRPr lang="en-US" sz="1150" dirty="0"/>
           </a:p>
         </p:txBody>
       </p:sp>
       <p:sp>
         <p:nvSpPr>
-          <p:cNvPr id="41" name="Text 39"/>
+          <p:cNvPr id="36" name="Text 34"/>
           <p:cNvSpPr txBox="1"/>
           <p:nvPr/>
         </p:nvSpPr>
@@ -18066,18 +17450,18 @@
       </p:sp>
       <p:sp>
         <p:nvSpPr>
-          <p:cNvPr id="42" name="Shape 40"/>
+          <p:cNvPr id="37" name="Shape 35"/>
           <p:cNvSpPr/>
           <p:nvPr/>
         </p:nvSpPr>
         <p:spPr>
           <a:xfrm>
             <a:off x="8560613" y="2403043"/>
-            <a:ext cx="3084271" cy="786384"/>
+            <a:ext cx="3084271" cy="1051560"/>
           </a:xfrm>
           <a:prstGeom prst="roundRect">
             <a:avLst>
-              <a:gd name="adj" fmla="val 6977"/>
+              <a:gd name="adj" fmla="val 5217"/>
             </a:avLst>
           </a:prstGeom>
           <a:solidFill>
@@ -18088,18 +17472,18 @@
       </p:sp>
       <p:sp>
         <p:nvSpPr>
-          <p:cNvPr id="43" name="Shape 41"/>
+          <p:cNvPr id="38" name="Shape 36"/>
           <p:cNvSpPr/>
           <p:nvPr/>
         </p:nvSpPr>
         <p:spPr>
           <a:xfrm>
             <a:off x="8540496" y="2377440"/>
-            <a:ext cx="3084271" cy="786384"/>
+            <a:ext cx="3084271" cy="1051560"/>
           </a:xfrm>
           <a:prstGeom prst="roundRect">
             <a:avLst>
-              <a:gd name="adj" fmla="val 6977"/>
+              <a:gd name="adj" fmla="val 5217"/>
             </a:avLst>
           </a:prstGeom>
           <a:solidFill>
@@ -18115,14 +17499,14 @@
       </p:sp>
       <p:sp>
         <p:nvSpPr>
-          <p:cNvPr id="44" name="Text 42"/>
+          <p:cNvPr id="39" name="Text 37"/>
           <p:cNvSpPr txBox="1"/>
           <p:nvPr/>
         </p:nvSpPr>
         <p:spPr>
           <a:xfrm>
-            <a:off x="8705088" y="2432304"/>
-            <a:ext cx="2755087" cy="329184"/>
+            <a:off x="8705088" y="2468880"/>
+            <a:ext cx="2755087" cy="457200"/>
           </a:xfrm>
           <a:prstGeom prst="rect">
             <a:avLst/>
@@ -18154,14 +17538,14 @@
       </p:sp>
       <p:sp>
         <p:nvSpPr>
-          <p:cNvPr id="45" name="Text 43"/>
+          <p:cNvPr id="40" name="Text 38"/>
           <p:cNvSpPr txBox="1"/>
           <p:nvPr/>
         </p:nvSpPr>
         <p:spPr>
           <a:xfrm>
-            <a:off x="8705088" y="2798064"/>
-            <a:ext cx="2755087" cy="329184"/>
+            <a:off x="8705088" y="2944368"/>
+            <a:ext cx="2755087" cy="420624"/>
           </a:xfrm>
           <a:prstGeom prst="rect">
             <a:avLst/>
@@ -18193,18 +17577,18 @@
       </p:sp>
       <p:sp>
         <p:nvSpPr>
-          <p:cNvPr id="46" name="Shape 44"/>
+          <p:cNvPr id="41" name="Shape 39"/>
           <p:cNvSpPr/>
           <p:nvPr/>
         </p:nvSpPr>
         <p:spPr>
           <a:xfrm>
-            <a:off x="8560613" y="3244291"/>
-            <a:ext cx="3084271" cy="786384"/>
+            <a:off x="8560613" y="3509467"/>
+            <a:ext cx="3084271" cy="1051560"/>
           </a:xfrm>
           <a:prstGeom prst="roundRect">
             <a:avLst>
-              <a:gd name="adj" fmla="val 6977"/>
+              <a:gd name="adj" fmla="val 5217"/>
             </a:avLst>
           </a:prstGeom>
           <a:solidFill>
@@ -18215,18 +17599,18 @@
       </p:sp>
       <p:sp>
         <p:nvSpPr>
-          <p:cNvPr id="47" name="Shape 45"/>
+          <p:cNvPr id="42" name="Shape 40"/>
           <p:cNvSpPr/>
           <p:nvPr/>
         </p:nvSpPr>
         <p:spPr>
           <a:xfrm>
-            <a:off x="8540496" y="3218688"/>
-            <a:ext cx="3084271" cy="786384"/>
+            <a:off x="8540496" y="3483864"/>
+            <a:ext cx="3084271" cy="1051560"/>
           </a:xfrm>
           <a:prstGeom prst="roundRect">
             <a:avLst>
-              <a:gd name="adj" fmla="val 6977"/>
+              <a:gd name="adj" fmla="val 5217"/>
             </a:avLst>
           </a:prstGeom>
           <a:solidFill>
@@ -18242,14 +17626,14 @@
       </p:sp>
       <p:sp>
         <p:nvSpPr>
-          <p:cNvPr id="48" name="Text 46"/>
+          <p:cNvPr id="43" name="Text 41"/>
           <p:cNvSpPr txBox="1"/>
           <p:nvPr/>
         </p:nvSpPr>
         <p:spPr>
           <a:xfrm>
-            <a:off x="8705088" y="3273552"/>
-            <a:ext cx="2755087" cy="329184"/>
+            <a:off x="8705088" y="3575304"/>
+            <a:ext cx="2755087" cy="457200"/>
           </a:xfrm>
           <a:prstGeom prst="rect">
             <a:avLst/>
@@ -18273,7 +17657,7 @@
                 <a:ea typeface="Calibri" pitchFamily="34" charset="-122"/>
                 <a:cs typeface="Calibri" pitchFamily="34" charset="-120"/>
               </a:rPr>
-              <a:t>Recovery Controller fails at Mid-1</a:t>
+              <a:t>Tier-2 gates fail at Mid-1</a:t>
             </a:r>
             <a:endParaRPr lang="en-US" sz="1230" dirty="0"/>
           </a:p>
@@ -18281,14 +17665,14 @@
       </p:sp>
       <p:sp>
         <p:nvSpPr>
-          <p:cNvPr id="49" name="Text 47"/>
+          <p:cNvPr id="44" name="Text 42"/>
           <p:cNvSpPr txBox="1"/>
           <p:nvPr/>
         </p:nvSpPr>
         <p:spPr>
           <a:xfrm>
-            <a:off x="8705088" y="3639312"/>
-            <a:ext cx="2755087" cy="329184"/>
+            <a:off x="8705088" y="4050792"/>
+            <a:ext cx="2755087" cy="420624"/>
           </a:xfrm>
           <a:prstGeom prst="rect">
             <a:avLst/>
@@ -18312,7 +17696,7 @@
                 <a:ea typeface="Calibri" pitchFamily="34" charset="-122"/>
                 <a:cs typeface="Calibri" pitchFamily="34" charset="-120"/>
               </a:rPr>
-              <a:t>Resume via controlled replay — Tier 1 delivers it</a:t>
+              <a:t>Recovery Controller / Verified Repair Memory — Tier 1 already delivers the core; Tier 2 ships as a memory on/off ablation</a:t>
             </a:r>
             <a:endParaRPr lang="en-US" sz="1130" dirty="0"/>
           </a:p>
@@ -18320,18 +17704,18 @@
       </p:sp>
       <p:sp>
         <p:nvSpPr>
-          <p:cNvPr id="50" name="Shape 48"/>
+          <p:cNvPr id="45" name="Shape 43"/>
           <p:cNvSpPr/>
           <p:nvPr/>
         </p:nvSpPr>
         <p:spPr>
           <a:xfrm>
-            <a:off x="8560613" y="4085539"/>
-            <a:ext cx="3084271" cy="786384"/>
+            <a:off x="8560613" y="4615891"/>
+            <a:ext cx="3084271" cy="1051560"/>
           </a:xfrm>
           <a:prstGeom prst="roundRect">
             <a:avLst>
-              <a:gd name="adj" fmla="val 6977"/>
+              <a:gd name="adj" fmla="val 5217"/>
             </a:avLst>
           </a:prstGeom>
           <a:solidFill>
@@ -18342,18 +17726,18 @@
       </p:sp>
       <p:sp>
         <p:nvSpPr>
-          <p:cNvPr id="51" name="Shape 49"/>
+          <p:cNvPr id="46" name="Shape 44"/>
           <p:cNvSpPr/>
           <p:nvPr/>
         </p:nvSpPr>
         <p:spPr>
           <a:xfrm>
-            <a:off x="8540496" y="4059936"/>
-            <a:ext cx="3084271" cy="786384"/>
+            <a:off x="8540496" y="4590288"/>
+            <a:ext cx="3084271" cy="1051560"/>
           </a:xfrm>
           <a:prstGeom prst="roundRect">
             <a:avLst>
-              <a:gd name="adj" fmla="val 6977"/>
+              <a:gd name="adj" fmla="val 5217"/>
             </a:avLst>
           </a:prstGeom>
           <a:solidFill>
@@ -18369,14 +17753,14 @@
       </p:sp>
       <p:sp>
         <p:nvSpPr>
-          <p:cNvPr id="52" name="Text 50"/>
+          <p:cNvPr id="47" name="Text 45"/>
           <p:cNvSpPr txBox="1"/>
           <p:nvPr/>
         </p:nvSpPr>
         <p:spPr>
           <a:xfrm>
-            <a:off x="8705088" y="4114800"/>
-            <a:ext cx="2755087" cy="329184"/>
+            <a:off x="8705088" y="4681728"/>
+            <a:ext cx="2755087" cy="457200"/>
           </a:xfrm>
           <a:prstGeom prst="rect">
             <a:avLst/>
@@ -18400,7 +17784,7 @@
                 <a:ea typeface="Calibri" pitchFamily="34" charset="-122"/>
                 <a:cs typeface="Calibri" pitchFamily="34" charset="-120"/>
               </a:rPr>
-              <a:t>Verified Repair Memory fails again</a:t>
+              <a:t>Benchmark scale stalls below 500</a:t>
             </a:r>
             <a:endParaRPr lang="en-US" sz="1230" dirty="0"/>
           </a:p>
@@ -18408,14 +17792,14 @@
       </p:sp>
       <p:sp>
         <p:nvSpPr>
-          <p:cNvPr id="53" name="Text 51"/>
+          <p:cNvPr id="48" name="Text 46"/>
           <p:cNvSpPr txBox="1"/>
           <p:nvPr/>
         </p:nvSpPr>
         <p:spPr>
           <a:xfrm>
-            <a:off x="8705088" y="4480560"/>
-            <a:ext cx="2755087" cy="329184"/>
+            <a:off x="8705088" y="5157216"/>
+            <a:ext cx="2755087" cy="420624"/>
           </a:xfrm>
           <a:prstGeom prst="rect">
             <a:avLst/>
@@ -18439,7 +17823,7 @@
                 <a:ea typeface="Calibri" pitchFamily="34" charset="-122"/>
                 <a:cs typeface="Calibri" pitchFamily="34" charset="-120"/>
               </a:rPr>
-              <a:t>Ships as a memory-on/off ablation</a:t>
+              <a:t>Floor of 500; 300-with-stats beats 1,000-without</a:t>
             </a:r>
             <a:endParaRPr lang="en-US" sz="1130" dirty="0"/>
           </a:p>
@@ -18447,134 +17831,7 @@
       </p:sp>
       <p:sp>
         <p:nvSpPr>
-          <p:cNvPr id="54" name="Shape 52"/>
-          <p:cNvSpPr/>
-          <p:nvPr/>
-        </p:nvSpPr>
-        <p:spPr>
-          <a:xfrm>
-            <a:off x="8560613" y="4926787"/>
-            <a:ext cx="3084271" cy="786384"/>
-          </a:xfrm>
-          <a:prstGeom prst="roundRect">
-            <a:avLst>
-              <a:gd name="adj" fmla="val 6977"/>
-            </a:avLst>
-          </a:prstGeom>
-          <a:solidFill>
-            <a:srgbClr val="E4E6EB"/>
-          </a:solidFill>
-          <a:ln/>
-        </p:spPr>
-      </p:sp>
-      <p:sp>
-        <p:nvSpPr>
-          <p:cNvPr id="55" name="Shape 53"/>
-          <p:cNvSpPr/>
-          <p:nvPr/>
-        </p:nvSpPr>
-        <p:spPr>
-          <a:xfrm>
-            <a:off x="8540496" y="4901184"/>
-            <a:ext cx="3084271" cy="786384"/>
-          </a:xfrm>
-          <a:prstGeom prst="roundRect">
-            <a:avLst>
-              <a:gd name="adj" fmla="val 6977"/>
-            </a:avLst>
-          </a:prstGeom>
-          <a:solidFill>
-            <a:srgbClr val="F1F2F5"/>
-          </a:solidFill>
-          <a:ln w="9525">
-            <a:solidFill>
-              <a:srgbClr val="D9DCE3"/>
-            </a:solidFill>
-            <a:prstDash val="solid"/>
-          </a:ln>
-        </p:spPr>
-      </p:sp>
-      <p:sp>
-        <p:nvSpPr>
-          <p:cNvPr id="56" name="Text 54"/>
-          <p:cNvSpPr txBox="1"/>
-          <p:nvPr/>
-        </p:nvSpPr>
-        <p:spPr>
-          <a:xfrm>
-            <a:off x="8705088" y="4956048"/>
-            <a:ext cx="2755087" cy="329184"/>
-          </a:xfrm>
-          <a:prstGeom prst="rect">
-            <a:avLst/>
-          </a:prstGeom>
-          <a:noFill/>
-          <a:ln/>
-        </p:spPr>
-        <p:txBody>
-          <a:bodyPr wrap="square" lIns="0" tIns="0" rIns="0" bIns="0" rtlCol="0" anchor="ctr"/>
-          <a:lstStyle/>
-          <a:p>
-            <a:pPr indent="0" marL="0">
-              <a:buNone/>
-            </a:pPr>
-            <a:r>
-              <a:rPr lang="en-US" sz="1230" b="1" dirty="0">
-                <a:solidFill>
-                  <a:srgbClr val="1B202A"/>
-                </a:solidFill>
-                <a:latin typeface="Calibri" pitchFamily="34" charset="0"/>
-                <a:ea typeface="Calibri" pitchFamily="34" charset="-122"/>
-                <a:cs typeface="Calibri" pitchFamily="34" charset="-120"/>
-              </a:rPr>
-              <a:t>Benchmark scale stalls below 500</a:t>
-            </a:r>
-            <a:endParaRPr lang="en-US" sz="1230" dirty="0"/>
-          </a:p>
-        </p:txBody>
-      </p:sp>
-      <p:sp>
-        <p:nvSpPr>
-          <p:cNvPr id="57" name="Text 55"/>
-          <p:cNvSpPr txBox="1"/>
-          <p:nvPr/>
-        </p:nvSpPr>
-        <p:spPr>
-          <a:xfrm>
-            <a:off x="8705088" y="5321808"/>
-            <a:ext cx="2755087" cy="329184"/>
-          </a:xfrm>
-          <a:prstGeom prst="rect">
-            <a:avLst/>
-          </a:prstGeom>
-          <a:noFill/>
-          <a:ln/>
-        </p:spPr>
-        <p:txBody>
-          <a:bodyPr wrap="square" lIns="0" tIns="0" rIns="0" bIns="0" rtlCol="0" anchor="ctr"/>
-          <a:lstStyle/>
-          <a:p>
-            <a:pPr indent="0" marL="0">
-              <a:buNone/>
-            </a:pPr>
-            <a:r>
-              <a:rPr lang="en-US" sz="1130" dirty="0">
-                <a:solidFill>
-                  <a:srgbClr val="1E7A52"/>
-                </a:solidFill>
-                <a:latin typeface="Calibri" pitchFamily="34" charset="0"/>
-                <a:ea typeface="Calibri" pitchFamily="34" charset="-122"/>
-                <a:cs typeface="Calibri" pitchFamily="34" charset="-120"/>
-              </a:rPr>
-              <a:t>Floor of 500; 300-with-stats beats 1,000-without</a:t>
-            </a:r>
-            <a:endParaRPr lang="en-US" sz="1130" dirty="0"/>
-          </a:p>
-        </p:txBody>
-      </p:sp>
-      <p:sp>
-        <p:nvSpPr>
-          <p:cNvPr id="58" name="Shape 56"/>
+          <p:cNvPr id="49" name="Shape 47"/>
           <p:cNvSpPr/>
           <p:nvPr/>
         </p:nvSpPr>
@@ -18596,7 +17853,7 @@
       </p:sp>
       <p:sp>
         <p:nvSpPr>
-          <p:cNvPr id="59" name="Shape 57"/>
+          <p:cNvPr id="50" name="Shape 48"/>
           <p:cNvSpPr/>
           <p:nvPr/>
         </p:nvSpPr>
@@ -18623,7 +17880,7 @@
       </p:sp>
       <p:sp>
         <p:nvSpPr>
-          <p:cNvPr id="60" name="Shape 58"/>
+          <p:cNvPr id="51" name="Shape 49"/>
           <p:cNvSpPr/>
           <p:nvPr/>
         </p:nvSpPr>
@@ -18643,7 +17900,7 @@
       </p:sp>
       <p:sp>
         <p:nvSpPr>
-          <p:cNvPr id="61" name="Text 59"/>
+          <p:cNvPr id="52" name="Text 50"/>
           <p:cNvSpPr txBox="1"/>
           <p:nvPr/>
         </p:nvSpPr>

</xml_diff>

<commit_message>
style: closing slide down to two lines
Slide 12 was carrying a paragraph, a restated claim, the team block and the
supervisor block. Stripped to "Thank you" and "Any questions?" on the same
dark ground, block re-centred vertically now that it holds two lines.

This slide stays on screen for the whole Q&A, so anything on it competes with
the person answering. Team names and the supervisor are already on slide 1 if
the panel needs them.

The two things worth saying during Q&A moved into the speaker note rather than
being deleted: the offer to open any spike file on request, and the prepared
honest answer to a weakness question. Both are better said out loud than read
off a slide.

Verified: 12 slides, fade transitions intact, no malformed XML.
</commit_message>
<xml_diff>
--- a/markdowns/05-deliverables/proposal-deck/Granite_Proposal_Defense_v2.pptx
+++ b/markdowns/05-deliverables/proposal-deck/Granite_Proposal_Defense_v2.pptx
@@ -1024,7 +1024,7 @@
           <a:p>
             <a:r>
               <a:rPr lang="en-US" dirty="0"/>
-              <a:t>Do not rush off this slide — it stays up for the whole Q&amp;A, so the project identity is what the panel is looking at while they question you. The offer to open a file is genuine and should be made out loud, not left on the slide: the spike outputs are in dev/spikes/poc/ and any of them can be shown live. If the panel opens with a broad question, the restated claim above is the frame to answer within — attribution, silent-failure detection and verified repair, measured as one pipeline. Lead any weakness question with the honest answer already prepared: step accuracy is 13.2% against a published 59.5% on a simplified reproduction, Spike 7 is a reported negative, and two of the ten committed mechanisms carry pre-registered Mid-1 gates.</a:t>
+              <a:t>This slide stays up for the whole Q&amp;A — do not click away from it. It is deliberately bare so nothing on screen competes with the person answering. Two things to say out loud rather than put on the slide: every figure in this deck is recomputable from a file in dev/spikes/poc/ and we will open any of them on request; and if a weakness question comes, lead with the honest answer already prepared — step accuracy is 13.2% against a published 59.5% on a simplified two-stage reproduction, Spike 7 is a reported negative, and two of the ten committed mechanisms carry pre-registered Mid-1 decision gates. Team names and the supervisor are on slide 1 if the panel needs them.</a:t>
             </a:r>
             <a:endParaRPr lang="en-US" dirty="0"/>
           </a:p>
@@ -5313,7 +5313,7 @@
         </p:nvSpPr>
         <p:spPr>
           <a:xfrm>
-            <a:off x="566928" y="1325880"/>
+            <a:off x="566928" y="2395728"/>
             <a:ext cx="8412480" cy="274320"/>
           </a:xfrm>
           <a:prstGeom prst="rect">
@@ -5352,7 +5352,7 @@
         </p:nvSpPr>
         <p:spPr>
           <a:xfrm>
-            <a:off x="566928" y="1700784"/>
+            <a:off x="566928" y="2761488"/>
             <a:ext cx="8412480" cy="1051560"/>
           </a:xfrm>
           <a:prstGeom prst="rect">
@@ -5385,14 +5385,34 @@
       </p:sp>
       <p:sp>
         <p:nvSpPr>
-          <p:cNvPr id="8" name="Text 6"/>
+          <p:cNvPr id="8" name="Shape 6"/>
+          <p:cNvSpPr/>
+          <p:nvPr/>
+        </p:nvSpPr>
+        <p:spPr>
+          <a:xfrm>
+            <a:off x="566928" y="3968496"/>
+            <a:ext cx="1005840" cy="32004"/>
+          </a:xfrm>
+          <a:prstGeom prst="rect">
+            <a:avLst/>
+          </a:prstGeom>
+          <a:solidFill>
+            <a:srgbClr val="C89B3C"/>
+          </a:solidFill>
+          <a:ln/>
+        </p:spPr>
+      </p:sp>
+      <p:sp>
+        <p:nvSpPr>
+          <p:cNvPr id="9" name="Text 7"/>
           <p:cNvSpPr txBox="1"/>
           <p:nvPr/>
         </p:nvSpPr>
         <p:spPr>
           <a:xfrm>
-            <a:off x="566928" y="2798064"/>
-            <a:ext cx="7863840" cy="731520"/>
+            <a:off x="566928" y="4187952"/>
+            <a:ext cx="8412480" cy="566928"/>
           </a:xfrm>
           <a:prstGeom prst="rect">
             <a:avLst/>
@@ -5408,337 +5428,17 @@
               <a:buNone/>
             </a:pPr>
             <a:r>
-              <a:rPr lang="en-US" sz="2100" i="1" dirty="0">
+              <a:rPr lang="en-US" sz="3000" i="1" dirty="0">
                 <a:solidFill>
                   <a:srgbClr val="A9B0BE"/>
-                </a:solidFill>
-                <a:latin typeface="Calibri" pitchFamily="34" charset="0"/>
-                <a:ea typeface="Calibri" pitchFamily="34" charset="-122"/>
-                <a:cs typeface="Calibri" pitchFamily="34" charset="-120"/>
-              </a:rPr>
-              <a:t>Questions welcome — every figure on these slides is recomputable from a file in the repository, and we are happy to open any one of them.</a:t>
-            </a:r>
-            <a:endParaRPr lang="en-US" sz="2100" dirty="0"/>
-          </a:p>
-        </p:txBody>
-      </p:sp>
-      <p:sp>
-        <p:nvSpPr>
-          <p:cNvPr id="9" name="Shape 7"/>
-          <p:cNvSpPr/>
-          <p:nvPr/>
-        </p:nvSpPr>
-        <p:spPr>
-          <a:xfrm>
-            <a:off x="566928" y="3712464"/>
-            <a:ext cx="1005840" cy="32004"/>
-          </a:xfrm>
-          <a:prstGeom prst="rect">
-            <a:avLst/>
-          </a:prstGeom>
-          <a:solidFill>
-            <a:srgbClr val="C89B3C"/>
-          </a:solidFill>
-          <a:ln/>
-        </p:spPr>
-      </p:sp>
-      <p:sp>
-        <p:nvSpPr>
-          <p:cNvPr id="10" name="Text 8"/>
-          <p:cNvSpPr txBox="1"/>
-          <p:nvPr/>
-        </p:nvSpPr>
-        <p:spPr>
-          <a:xfrm>
-            <a:off x="566928" y="3931920"/>
-            <a:ext cx="8412480" cy="914400"/>
-          </a:xfrm>
-          <a:prstGeom prst="rect">
-            <a:avLst/>
-          </a:prstGeom>
-          <a:noFill/>
-          <a:ln/>
-        </p:spPr>
-        <p:txBody>
-          <a:bodyPr wrap="square" lIns="0" tIns="0" rIns="0" bIns="0" rtlCol="0" anchor="ctr"/>
-          <a:lstStyle/>
-          <a:p>
-            <a:pPr indent="0" marL="0">
-              <a:buNone/>
-            </a:pPr>
-            <a:r>
-              <a:rPr lang="en-US" sz="2300" i="1" dirty="0">
-                <a:solidFill>
-                  <a:srgbClr val="F5F6F8"/>
                 </a:solidFill>
                 <a:latin typeface="Georgia" pitchFamily="34" charset="0"/>
                 <a:ea typeface="Georgia" pitchFamily="34" charset="-122"/>
                 <a:cs typeface="Georgia" pitchFamily="34" charset="-120"/>
               </a:rPr>
-              <a:t>Attribution, silent-failure detection and verified repair — measured as one pipeline, on architectures no prior paper tested.</a:t>
-            </a:r>
-            <a:endParaRPr lang="en-US" sz="2300" dirty="0"/>
-          </a:p>
-        </p:txBody>
-      </p:sp>
-      <p:sp>
-        <p:nvSpPr>
-          <p:cNvPr id="11" name="Shape 9"/>
-          <p:cNvSpPr/>
-          <p:nvPr/>
-        </p:nvSpPr>
-        <p:spPr>
-          <a:xfrm>
-            <a:off x="566928" y="5138928"/>
-            <a:ext cx="7680960" cy="0"/>
-          </a:xfrm>
-          <a:prstGeom prst="line">
-            <a:avLst/>
-          </a:prstGeom>
-          <a:noFill/>
-          <a:ln w="12700">
-            <a:solidFill>
-              <a:srgbClr val="2C3340"/>
-            </a:solidFill>
-            <a:prstDash val="solid"/>
-          </a:ln>
-        </p:spPr>
-      </p:sp>
-      <p:sp>
-        <p:nvSpPr>
-          <p:cNvPr id="12" name="Text 10"/>
-          <p:cNvSpPr txBox="1"/>
-          <p:nvPr/>
-        </p:nvSpPr>
-        <p:spPr>
-          <a:xfrm>
-            <a:off x="566928" y="5266944"/>
-            <a:ext cx="2560320" cy="658368"/>
-          </a:xfrm>
-          <a:prstGeom prst="rect">
-            <a:avLst/>
-          </a:prstGeom>
-          <a:noFill/>
-          <a:ln/>
-        </p:spPr>
-        <p:txBody>
-          <a:bodyPr wrap="square" lIns="0" tIns="0" rIns="0" bIns="0" rtlCol="0" anchor="ctr"/>
-          <a:lstStyle/>
-          <a:p>
-            <a:pPr indent="0" marL="0">
-              <a:buNone/>
-            </a:pPr>
-            <a:r>
-              <a:rPr lang="en-US" sz="1800" b="1" dirty="0">
-                <a:solidFill>
-                  <a:srgbClr val="F5F6F8"/>
-                </a:solidFill>
-                <a:latin typeface="Calibri" pitchFamily="34" charset="0"/>
-                <a:ea typeface="Calibri" pitchFamily="34" charset="-122"/>
-                <a:cs typeface="Calibri" pitchFamily="34" charset="-120"/>
-              </a:rPr>
-              <a:t>Shahoud Shahid</a:t>
-            </a:r>
-            <a:endParaRPr lang="en-US" sz="1800" dirty="0"/>
-          </a:p>
-          <a:p>
-            <a:pPr indent="0" marL="0">
-              <a:buNone/>
-            </a:pPr>
-            <a:r>
-              <a:rPr lang="en-US" sz="1500" dirty="0">
-                <a:solidFill>
-                  <a:srgbClr val="A9B0BE"/>
-                </a:solidFill>
-                <a:latin typeface="Calibri" pitchFamily="34" charset="0"/>
-                <a:ea typeface="Calibri" pitchFamily="34" charset="-122"/>
-                <a:cs typeface="Calibri" pitchFamily="34" charset="-120"/>
-              </a:rPr>
-              <a:t>23i-2515</a:t>
-            </a:r>
-            <a:endParaRPr lang="en-US" sz="1800" dirty="0"/>
-          </a:p>
-        </p:txBody>
-      </p:sp>
-      <p:sp>
-        <p:nvSpPr>
-          <p:cNvPr id="13" name="Text 11"/>
-          <p:cNvSpPr txBox="1"/>
-          <p:nvPr/>
-        </p:nvSpPr>
-        <p:spPr>
-          <a:xfrm>
-            <a:off x="3172968" y="5266944"/>
-            <a:ext cx="2560320" cy="658368"/>
-          </a:xfrm>
-          <a:prstGeom prst="rect">
-            <a:avLst/>
-          </a:prstGeom>
-          <a:noFill/>
-          <a:ln/>
-        </p:spPr>
-        <p:txBody>
-          <a:bodyPr wrap="square" lIns="0" tIns="0" rIns="0" bIns="0" rtlCol="0" anchor="ctr"/>
-          <a:lstStyle/>
-          <a:p>
-            <a:pPr indent="0" marL="0">
-              <a:buNone/>
-            </a:pPr>
-            <a:r>
-              <a:rPr lang="en-US" sz="1800" b="1" dirty="0">
-                <a:solidFill>
-                  <a:srgbClr val="F5F6F8"/>
-                </a:solidFill>
-                <a:latin typeface="Calibri" pitchFamily="34" charset="0"/>
-                <a:ea typeface="Calibri" pitchFamily="34" charset="-122"/>
-                <a:cs typeface="Calibri" pitchFamily="34" charset="-120"/>
-              </a:rPr>
-              <a:t>Muhammad Noor</a:t>
-            </a:r>
-            <a:endParaRPr lang="en-US" sz="1800" dirty="0"/>
-          </a:p>
-          <a:p>
-            <a:pPr indent="0" marL="0">
-              <a:buNone/>
-            </a:pPr>
-            <a:r>
-              <a:rPr lang="en-US" sz="1500" dirty="0">
-                <a:solidFill>
-                  <a:srgbClr val="A9B0BE"/>
-                </a:solidFill>
-                <a:latin typeface="Calibri" pitchFamily="34" charset="0"/>
-                <a:ea typeface="Calibri" pitchFamily="34" charset="-122"/>
-                <a:cs typeface="Calibri" pitchFamily="34" charset="-120"/>
-              </a:rPr>
-              <a:t>23i-2520</a:t>
-            </a:r>
-            <a:endParaRPr lang="en-US" sz="1800" dirty="0"/>
-          </a:p>
-        </p:txBody>
-      </p:sp>
-      <p:sp>
-        <p:nvSpPr>
-          <p:cNvPr id="14" name="Text 12"/>
-          <p:cNvSpPr txBox="1"/>
-          <p:nvPr/>
-        </p:nvSpPr>
-        <p:spPr>
-          <a:xfrm>
-            <a:off x="5779008" y="5266944"/>
-            <a:ext cx="2560320" cy="658368"/>
-          </a:xfrm>
-          <a:prstGeom prst="rect">
-            <a:avLst/>
-          </a:prstGeom>
-          <a:noFill/>
-          <a:ln/>
-        </p:spPr>
-        <p:txBody>
-          <a:bodyPr wrap="square" lIns="0" tIns="0" rIns="0" bIns="0" rtlCol="0" anchor="ctr"/>
-          <a:lstStyle/>
-          <a:p>
-            <a:pPr indent="0" marL="0">
-              <a:buNone/>
-            </a:pPr>
-            <a:r>
-              <a:rPr lang="en-US" sz="1800" b="1" dirty="0">
-                <a:solidFill>
-                  <a:srgbClr val="F5F6F8"/>
-                </a:solidFill>
-                <a:latin typeface="Calibri" pitchFamily="34" charset="0"/>
-                <a:ea typeface="Calibri" pitchFamily="34" charset="-122"/>
-                <a:cs typeface="Calibri" pitchFamily="34" charset="-120"/>
-              </a:rPr>
-              <a:t>Saif Shahzad</a:t>
-            </a:r>
-            <a:endParaRPr lang="en-US" sz="1800" dirty="0"/>
-          </a:p>
-          <a:p>
-            <a:pPr indent="0" marL="0">
-              <a:buNone/>
-            </a:pPr>
-            <a:r>
-              <a:rPr lang="en-US" sz="1500" dirty="0">
-                <a:solidFill>
-                  <a:srgbClr val="A9B0BE"/>
-                </a:solidFill>
-                <a:latin typeface="Calibri" pitchFamily="34" charset="0"/>
-                <a:ea typeface="Calibri" pitchFamily="34" charset="-122"/>
-                <a:cs typeface="Calibri" pitchFamily="34" charset="-120"/>
-              </a:rPr>
-              <a:t>23i-2634</a:t>
-            </a:r>
-            <a:endParaRPr lang="en-US" sz="1800" dirty="0"/>
-          </a:p>
-        </p:txBody>
-      </p:sp>
-      <p:sp>
-        <p:nvSpPr>
-          <p:cNvPr id="15" name="Text 13"/>
-          <p:cNvSpPr txBox="1"/>
-          <p:nvPr/>
-        </p:nvSpPr>
-        <p:spPr>
-          <a:xfrm>
-            <a:off x="566928" y="6016752"/>
-            <a:ext cx="6400800" cy="658368"/>
-          </a:xfrm>
-          <a:prstGeom prst="rect">
-            <a:avLst/>
-          </a:prstGeom>
-          <a:noFill/>
-          <a:ln/>
-        </p:spPr>
-        <p:txBody>
-          <a:bodyPr wrap="square" lIns="0" tIns="0" rIns="0" bIns="0" rtlCol="0" anchor="ctr"/>
-          <a:lstStyle/>
-          <a:p>
-            <a:pPr indent="0" marL="0">
-              <a:buNone/>
-            </a:pPr>
-            <a:r>
-              <a:rPr lang="en-US" sz="1500" dirty="0">
-                <a:solidFill>
-                  <a:srgbClr val="A9B0BE"/>
-                </a:solidFill>
-                <a:latin typeface="Calibri" pitchFamily="34" charset="0"/>
-                <a:ea typeface="Calibri" pitchFamily="34" charset="-122"/>
-                <a:cs typeface="Calibri" pitchFamily="34" charset="-120"/>
-              </a:rPr>
-              <a:t>Supervisor   </a:t>
-            </a:r>
-            <a:pPr indent="0" marL="0">
-              <a:buNone/>
-            </a:pPr>
-            <a:r>
-              <a:rPr lang="en-US" sz="1800" b="1" dirty="0">
-                <a:solidFill>
-                  <a:srgbClr val="F5F6F8"/>
-                </a:solidFill>
-                <a:latin typeface="Calibri" pitchFamily="34" charset="0"/>
-                <a:ea typeface="Calibri" pitchFamily="34" charset="-122"/>
-                <a:cs typeface="Calibri" pitchFamily="34" charset="-120"/>
-              </a:rPr>
-              <a:t>Dr. Adil Majeed</a:t>
-            </a:r>
-            <a:endParaRPr lang="en-US" sz="1500" dirty="0"/>
-          </a:p>
-          <a:p>
-            <a:pPr indent="0" marL="0">
-              <a:buNone/>
-            </a:pPr>
-            <a:r>
-              <a:rPr lang="en-US" sz="1500" dirty="0">
-                <a:solidFill>
-                  <a:srgbClr val="A9B0BE"/>
-                </a:solidFill>
-                <a:latin typeface="Calibri" pitchFamily="34" charset="0"/>
-                <a:ea typeface="Calibri" pitchFamily="34" charset="-122"/>
-                <a:cs typeface="Calibri" pitchFamily="34" charset="-120"/>
-              </a:rPr>
-              <a:t>FAST School of Computing, NUCES Islamabad</a:t>
-            </a:r>
-            <a:endParaRPr lang="en-US" sz="1500" dirty="0"/>
+              <a:t>Any questions?</a:t>
+            </a:r>
+            <a:endParaRPr lang="en-US" sz="3000" dirty="0"/>
           </a:p>
         </p:txBody>
       </p:sp>

</xml_diff>